<commit_message>
Polish slide wording, add hypotheses slide, sync speaker text
</commit_message>
<xml_diff>
--- a/Презентация_распад_СССР.pptx
+++ b/Презентация_распад_СССР.pptx
@@ -20,6 +20,7 @@
     <p:sldId id="268" r:id="rId19"/>
     <p:sldId id="269" r:id="rId20"/>
     <p:sldId id="270" r:id="rId21"/>
+    <p:sldId id="271" r:id="rId22"/>
   </p:sldIdLst>
   <p:sldSz cx="12191695" cy="6858000" type="screen4x3"/>
   <p:notesSz cx="6858000" cy="9144000"/>
@@ -4245,7 +4246,7 @@
                 </a:solidFill>
                 <a:latin typeface="Trebuchet MS"/>
               </a:rPr>
-              <a:t>Единственная серия с отрицательным Y — уклон к «распад был неизбежен».</a:t>
+              <a:t>Единственная серия с отрицательным Y — уклон к тезису о неизбежности распада.</a:t>
             </a:r>
           </a:p>
         </p:txBody>
@@ -5269,7 +5270,7 @@
             <a:avLst/>
           </a:prstGeom>
           <a:solidFill>
-            <a:srgbClr val="1E2761"/>
+            <a:srgbClr val="FFFFFF"/>
           </a:solidFill>
           <a:ln>
             <a:noFill/>
@@ -5306,7 +5307,7 @@
         </p:nvSpPr>
         <p:spPr>
           <a:xfrm>
-            <a:off x="822960" y="640080"/>
+            <a:off x="822960" y="457200"/>
             <a:ext cx="10515600" cy="640080"/>
           </a:xfrm>
           <a:prstGeom prst="rect">
@@ -5326,27 +5327,66 @@
               </a:lnSpc>
             </a:pPr>
             <a:r>
-              <a:rPr sz="3400" b="1" i="0">
-                <a:solidFill>
-                  <a:srgbClr val="FFFFFF"/>
+              <a:rPr sz="3200" b="1" i="0">
+                <a:solidFill>
+                  <a:srgbClr val="1E2761"/>
                 </a:solidFill>
                 <a:latin typeface="Georgia"/>
               </a:rPr>
-              <a:t>Что это значит</a:t>
-            </a:r>
-          </a:p>
-        </p:txBody>
-      </p:sp>
-      <p:sp>
-        <p:nvSpPr>
-          <p:cNvPr id="4" name="Rounded Rectangle 3"/>
+              <a:t>Что стало с нашими гипотезами</a:t>
+            </a:r>
+          </a:p>
+        </p:txBody>
+      </p:sp>
+      <p:sp>
+        <p:nvSpPr>
+          <p:cNvPr id="4" name="TextBox 3"/>
+          <p:cNvSpPr txBox="1"/>
+          <p:nvPr/>
+        </p:nvSpPr>
+        <p:spPr>
+          <a:xfrm>
+            <a:off x="822960" y="1261872"/>
+            <a:ext cx="10515600" cy="457200"/>
+          </a:xfrm>
+          <a:prstGeom prst="rect">
+            <a:avLst/>
+          </a:prstGeom>
+          <a:noFill/>
+        </p:spPr>
+        <p:txBody>
+          <a:bodyPr wrap="square" anchor="t" lIns="0" rIns="0" tIns="0" bIns="0">
+            <a:spAutoFit/>
+          </a:bodyPr>
+          <a:lstStyle/>
+          <a:p>
+            <a:pPr algn="l">
+              <a:lnSpc>
+                <a:spcPct val="100000"/>
+              </a:lnSpc>
+            </a:pPr>
+            <a:r>
+              <a:rPr sz="1600" b="0" i="0">
+                <a:solidFill>
+                  <a:srgbClr val="6B7280"/>
+                </a:solidFill>
+                <a:latin typeface="Trebuchet MS"/>
+              </a:rPr>
+              <a:t>Шесть гипотез сформулировали до сбора данных. Вот что показали 360 ответов.</a:t>
+            </a:r>
+          </a:p>
+        </p:txBody>
+      </p:sp>
+      <p:sp>
+        <p:nvSpPr>
+          <p:cNvPr id="5" name="Rounded Rectangle 4"/>
           <p:cNvSpPr/>
           <p:nvPr/>
         </p:nvSpPr>
         <p:spPr>
           <a:xfrm>
-            <a:off x="822960" y="1645920"/>
-            <a:ext cx="10515600" cy="1554480"/>
+            <a:off x="822960" y="1783080"/>
+            <a:ext cx="10515600" cy="676656"/>
           </a:xfrm>
           <a:prstGeom prst="roundRect">
             <a:avLst>
@@ -5354,7 +5394,7 @@
             </a:avLst>
           </a:prstGeom>
           <a:solidFill>
-            <a:srgbClr val="2B3573"/>
+            <a:srgbClr val="F4F6FB"/>
           </a:solidFill>
           <a:ln>
             <a:noFill/>
@@ -5385,14 +5425,14 @@
       </p:sp>
       <p:sp>
         <p:nvSpPr>
-          <p:cNvPr id="5" name="TextBox 4"/>
-          <p:cNvSpPr txBox="1"/>
-          <p:nvPr/>
-        </p:nvSpPr>
-        <p:spPr>
-          <a:xfrm>
-            <a:off x="1188720" y="1874519"/>
-            <a:ext cx="9784080" cy="1097280"/>
+          <p:cNvPr id="6" name="TextBox 5"/>
+          <p:cNvSpPr txBox="1"/>
+          <p:nvPr/>
+        </p:nvSpPr>
+        <p:spPr>
+          <a:xfrm>
+            <a:off x="1005840" y="1783080"/>
+            <a:ext cx="685800" cy="676656"/>
           </a:xfrm>
           <a:prstGeom prst="rect">
             <a:avLst/>
@@ -5407,53 +5447,117 @@
           <a:p>
             <a:pPr algn="l">
               <a:lnSpc>
-                <a:spcPct val="115000"/>
-              </a:lnSpc>
-            </a:pPr>
-            <a:r>
-              <a:rPr sz="2000" b="1" i="0">
-                <a:solidFill>
-                  <a:srgbClr val="FFFFFF"/>
+                <a:spcPct val="100000"/>
+              </a:lnSpc>
+            </a:pPr>
+            <a:r>
+              <a:rPr sz="1800" b="1" i="0">
+                <a:solidFill>
+                  <a:srgbClr val="1E2761"/>
                 </a:solidFill>
                 <a:latin typeface="Georgia"/>
               </a:rPr>
-              <a:t>Культурного раскола «Россия против Запада» в базовой причинности мы не нашли.</a:t>
-            </a:r>
-          </a:p>
-          <a:p>
-            <a:pPr algn="l">
-              <a:lnSpc>
-                <a:spcPct val="115000"/>
-              </a:lnSpc>
-            </a:pPr>
-            <a:r>
-              <a:rPr sz="2000" b="1" i="0">
-                <a:solidFill>
-                  <a:srgbClr val="FFFFFF"/>
-                </a:solidFill>
-                <a:latin typeface="Georgia"/>
-              </a:rPr>
-              <a:t>Главный измеримый разрыв — не между моделями, а между моделями и людьми.</a:t>
-            </a:r>
-          </a:p>
-        </p:txBody>
-      </p:sp>
-      <p:sp>
-        <p:nvSpPr>
-          <p:cNvPr id="6" name="Oval 5"/>
+              <a:t>H1</a:t>
+            </a:r>
+          </a:p>
+        </p:txBody>
+      </p:sp>
+      <p:sp>
+        <p:nvSpPr>
+          <p:cNvPr id="7" name="TextBox 6"/>
+          <p:cNvSpPr txBox="1"/>
+          <p:nvPr/>
+        </p:nvSpPr>
+        <p:spPr>
+          <a:xfrm>
+            <a:off x="1737360" y="1783080"/>
+            <a:ext cx="4526280" cy="676656"/>
+          </a:xfrm>
+          <a:prstGeom prst="rect">
+            <a:avLst/>
+          </a:prstGeom>
+          <a:noFill/>
+        </p:spPr>
+        <p:txBody>
+          <a:bodyPr wrap="square" anchor="ctr" lIns="0" rIns="0" tIns="0" bIns="0">
+            <a:spAutoFit/>
+          </a:bodyPr>
+          <a:lstStyle/>
+          <a:p>
+            <a:pPr algn="l">
+              <a:lnSpc>
+                <a:spcPct val="104000"/>
+              </a:lnSpc>
+            </a:pPr>
+            <a:r>
+              <a:rPr sz="1350" b="0" i="0">
+                <a:solidFill>
+                  <a:srgbClr val="1F2937"/>
+                </a:solidFill>
+                <a:latin typeface="Trebuchet MS"/>
+              </a:rPr>
+              <a:t>Западные модели без поиска отвечают прямее и эмоциональнее</a:t>
+            </a:r>
+          </a:p>
+        </p:txBody>
+      </p:sp>
+      <p:sp>
+        <p:nvSpPr>
+          <p:cNvPr id="8" name="TextBox 7"/>
+          <p:cNvSpPr txBox="1"/>
+          <p:nvPr/>
+        </p:nvSpPr>
+        <p:spPr>
+          <a:xfrm>
+            <a:off x="6400800" y="1783080"/>
+            <a:ext cx="2560320" cy="676656"/>
+          </a:xfrm>
+          <a:prstGeom prst="rect">
+            <a:avLst/>
+          </a:prstGeom>
+          <a:noFill/>
+        </p:spPr>
+        <p:txBody>
+          <a:bodyPr wrap="square" anchor="ctr" lIns="0" rIns="0" tIns="0" bIns="0">
+            <a:spAutoFit/>
+          </a:bodyPr>
+          <a:lstStyle/>
+          <a:p>
+            <a:pPr algn="l">
+              <a:lnSpc>
+                <a:spcPct val="104000"/>
+              </a:lnSpc>
+            </a:pPr>
+            <a:r>
+              <a:rPr sz="1250" b="0" i="0">
+                <a:solidFill>
+                  <a:srgbClr val="6B7280"/>
+                </a:solidFill>
+                <a:latin typeface="Trebuchet MS"/>
+              </a:rPr>
+              <a:t>Gemini — да; ChatGPT и Claude сдержанны</a:t>
+            </a:r>
+          </a:p>
+        </p:txBody>
+      </p:sp>
+      <p:sp>
+        <p:nvSpPr>
+          <p:cNvPr id="9" name="Rounded Rectangle 8"/>
           <p:cNvSpPr/>
           <p:nvPr/>
         </p:nvSpPr>
         <p:spPr>
           <a:xfrm>
-            <a:off x="868680" y="3611880"/>
-            <a:ext cx="365760" cy="365760"/>
-          </a:xfrm>
-          <a:prstGeom prst="ellipse">
-            <a:avLst/>
+            <a:off x="9098280" y="1892808"/>
+            <a:ext cx="2103120" cy="457200"/>
+          </a:xfrm>
+          <a:prstGeom prst="roundRect">
+            <a:avLst>
+              <a:gd name="adj" fmla="val 35000"/>
+            </a:avLst>
           </a:prstGeom>
           <a:solidFill>
-            <a:srgbClr val="D7263D"/>
+            <a:srgbClr val="B56A00"/>
           </a:solidFill>
           <a:ln>
             <a:noFill/>
@@ -5484,98 +5588,61 @@
       </p:sp>
       <p:sp>
         <p:nvSpPr>
-          <p:cNvPr id="7" name="TextBox 6"/>
-          <p:cNvSpPr txBox="1"/>
-          <p:nvPr/>
-        </p:nvSpPr>
-        <p:spPr>
-          <a:xfrm>
-            <a:off x="1463040" y="3520440"/>
-            <a:ext cx="9692640" cy="457200"/>
-          </a:xfrm>
-          <a:prstGeom prst="rect">
-            <a:avLst/>
-          </a:prstGeom>
-          <a:noFill/>
-        </p:spPr>
-        <p:txBody>
-          <a:bodyPr wrap="square" anchor="t" lIns="0" rIns="0" tIns="0" bIns="0">
-            <a:spAutoFit/>
-          </a:bodyPr>
-          <a:lstStyle/>
-          <a:p>
-            <a:pPr algn="l">
+          <p:cNvPr id="10" name="TextBox 9"/>
+          <p:cNvSpPr txBox="1"/>
+          <p:nvPr/>
+        </p:nvSpPr>
+        <p:spPr>
+          <a:xfrm>
+            <a:off x="9098280" y="1892808"/>
+            <a:ext cx="2103120" cy="457200"/>
+          </a:xfrm>
+          <a:prstGeom prst="rect">
+            <a:avLst/>
+          </a:prstGeom>
+          <a:noFill/>
+        </p:spPr>
+        <p:txBody>
+          <a:bodyPr wrap="square" anchor="ctr" lIns="0" rIns="0" tIns="0" bIns="0">
+            <a:spAutoFit/>
+          </a:bodyPr>
+          <a:lstStyle/>
+          <a:p>
+            <a:pPr algn="ctr">
               <a:lnSpc>
                 <a:spcPct val="100000"/>
               </a:lnSpc>
             </a:pPr>
             <a:r>
-              <a:rPr sz="1800" b="1" i="0">
-                <a:solidFill>
-                  <a:srgbClr val="CADCFC"/>
-                </a:solidFill>
-                <a:latin typeface="Georgia"/>
-              </a:rPr>
-              <a:t>Консенсус сильнее ожиданий</a:t>
-            </a:r>
-          </a:p>
-        </p:txBody>
-      </p:sp>
-      <p:sp>
-        <p:nvSpPr>
-          <p:cNvPr id="8" name="TextBox 7"/>
-          <p:cNvSpPr txBox="1"/>
-          <p:nvPr/>
-        </p:nvSpPr>
-        <p:spPr>
-          <a:xfrm>
-            <a:off x="1463040" y="3977640"/>
-            <a:ext cx="9692640" cy="502920"/>
-          </a:xfrm>
-          <a:prstGeom prst="rect">
-            <a:avLst/>
-          </a:prstGeom>
-          <a:noFill/>
-        </p:spPr>
-        <p:txBody>
-          <a:bodyPr wrap="square" anchor="t" lIns="0" rIns="0" tIns="0" bIns="0">
-            <a:spAutoFit/>
-          </a:bodyPr>
-          <a:lstStyle/>
-          <a:p>
-            <a:pPr algn="l">
-              <a:lnSpc>
-                <a:spcPct val="110000"/>
-              </a:lnSpc>
-            </a:pPr>
-            <a:r>
-              <a:rPr sz="1500" b="0" i="0">
-                <a:solidFill>
-                  <a:srgbClr val="C8D0E8"/>
+              <a:rPr sz="1250" b="1" i="0">
+                <a:solidFill>
+                  <a:srgbClr val="FFFFFF"/>
                 </a:solidFill>
                 <a:latin typeface="Trebuchet MS"/>
               </a:rPr>
-              <a:t>Все модели ведут к внутреннему системному кризису, а не к внешнему врагу или простой неизбежности.</a:t>
-            </a:r>
-          </a:p>
-        </p:txBody>
-      </p:sp>
-      <p:sp>
-        <p:nvSpPr>
-          <p:cNvPr id="9" name="Oval 8"/>
+              <a:t>Частично</a:t>
+            </a:r>
+          </a:p>
+        </p:txBody>
+      </p:sp>
+      <p:sp>
+        <p:nvSpPr>
+          <p:cNvPr id="11" name="Rounded Rectangle 10"/>
           <p:cNvSpPr/>
           <p:nvPr/>
         </p:nvSpPr>
         <p:spPr>
           <a:xfrm>
-            <a:off x="868680" y="4572000"/>
-            <a:ext cx="365760" cy="365760"/>
-          </a:xfrm>
-          <a:prstGeom prst="ellipse">
-            <a:avLst/>
+            <a:off x="822960" y="2532888"/>
+            <a:ext cx="10515600" cy="676656"/>
+          </a:xfrm>
+          <a:prstGeom prst="roundRect">
+            <a:avLst>
+              <a:gd name="adj" fmla="val 8000"/>
+            </a:avLst>
           </a:prstGeom>
           <a:solidFill>
-            <a:srgbClr val="D7263D"/>
+            <a:srgbClr val="F4F6FB"/>
           </a:solidFill>
           <a:ln>
             <a:noFill/>
@@ -5606,22 +5673,22 @@
       </p:sp>
       <p:sp>
         <p:nvSpPr>
-          <p:cNvPr id="10" name="TextBox 9"/>
-          <p:cNvSpPr txBox="1"/>
-          <p:nvPr/>
-        </p:nvSpPr>
-        <p:spPr>
-          <a:xfrm>
-            <a:off x="1463040" y="4480560"/>
-            <a:ext cx="9692640" cy="457200"/>
-          </a:xfrm>
-          <a:prstGeom prst="rect">
-            <a:avLst/>
-          </a:prstGeom>
-          <a:noFill/>
-        </p:spPr>
-        <p:txBody>
-          <a:bodyPr wrap="square" anchor="t" lIns="0" rIns="0" tIns="0" bIns="0">
+          <p:cNvPr id="12" name="TextBox 11"/>
+          <p:cNvSpPr txBox="1"/>
+          <p:nvPr/>
+        </p:nvSpPr>
+        <p:spPr>
+          <a:xfrm>
+            <a:off x="1005840" y="2532888"/>
+            <a:ext cx="685800" cy="676656"/>
+          </a:xfrm>
+          <a:prstGeom prst="rect">
+            <a:avLst/>
+          </a:prstGeom>
+          <a:noFill/>
+        </p:spPr>
+        <p:txBody>
+          <a:bodyPr wrap="square" anchor="ctr" lIns="0" rIns="0" tIns="0" bIns="0">
             <a:spAutoFit/>
           </a:bodyPr>
           <a:lstStyle/>
@@ -5634,70 +5701,111 @@
             <a:r>
               <a:rPr sz="1800" b="1" i="0">
                 <a:solidFill>
-                  <a:srgbClr val="CADCFC"/>
+                  <a:srgbClr val="1E2761"/>
                 </a:solidFill>
                 <a:latin typeface="Georgia"/>
               </a:rPr>
-              <a:t>Модели «площе» людей</a:t>
-            </a:r>
-          </a:p>
-        </p:txBody>
-      </p:sp>
-      <p:sp>
-        <p:nvSpPr>
-          <p:cNvPr id="11" name="TextBox 10"/>
-          <p:cNvSpPr txBox="1"/>
-          <p:nvPr/>
-        </p:nvSpPr>
-        <p:spPr>
-          <a:xfrm>
-            <a:off x="1463040" y="4937760"/>
-            <a:ext cx="9692640" cy="502920"/>
-          </a:xfrm>
-          <a:prstGeom prst="rect">
-            <a:avLst/>
-          </a:prstGeom>
-          <a:noFill/>
-        </p:spPr>
-        <p:txBody>
-          <a:bodyPr wrap="square" anchor="t" lIns="0" rIns="0" tIns="0" bIns="0">
-            <a:spAutoFit/>
-          </a:bodyPr>
-          <a:lstStyle/>
-          <a:p>
-            <a:pPr algn="l">
-              <a:lnSpc>
-                <a:spcPct val="110000"/>
-              </a:lnSpc>
-            </a:pPr>
-            <a:r>
-              <a:rPr sz="1500" b="0" i="0">
-                <a:solidFill>
-                  <a:srgbClr val="C8D0E8"/>
+              <a:t>H2</a:t>
+            </a:r>
+          </a:p>
+        </p:txBody>
+      </p:sp>
+      <p:sp>
+        <p:nvSpPr>
+          <p:cNvPr id="13" name="TextBox 12"/>
+          <p:cNvSpPr txBox="1"/>
+          <p:nvPr/>
+        </p:nvSpPr>
+        <p:spPr>
+          <a:xfrm>
+            <a:off x="1737360" y="2532888"/>
+            <a:ext cx="4526280" cy="676656"/>
+          </a:xfrm>
+          <a:prstGeom prst="rect">
+            <a:avLst/>
+          </a:prstGeom>
+          <a:noFill/>
+        </p:spPr>
+        <p:txBody>
+          <a:bodyPr wrap="square" anchor="ctr" lIns="0" rIns="0" tIns="0" bIns="0">
+            <a:spAutoFit/>
+          </a:bodyPr>
+          <a:lstStyle/>
+          <a:p>
+            <a:pPr algn="l">
+              <a:lnSpc>
+                <a:spcPct val="104000"/>
+              </a:lnSpc>
+            </a:pPr>
+            <a:r>
+              <a:rPr sz="1350" b="0" i="0">
+                <a:solidFill>
+                  <a:srgbClr val="1F2937"/>
                 </a:solidFill>
                 <a:latin typeface="Trebuchet MS"/>
               </a:rPr>
-              <a:t>По оси Y нейросети осторожнее: безличные структуры вместо конкретных решений живых историков.</a:t>
-            </a:r>
-          </a:p>
-        </p:txBody>
-      </p:sp>
-      <p:sp>
-        <p:nvSpPr>
-          <p:cNvPr id="12" name="Oval 11"/>
+              <a:t>Русские модели ближе к рос. источникам и сильнее винят Запад</a:t>
+            </a:r>
+          </a:p>
+        </p:txBody>
+      </p:sp>
+      <p:sp>
+        <p:nvSpPr>
+          <p:cNvPr id="14" name="TextBox 13"/>
+          <p:cNvSpPr txBox="1"/>
+          <p:nvPr/>
+        </p:nvSpPr>
+        <p:spPr>
+          <a:xfrm>
+            <a:off x="6400800" y="2532888"/>
+            <a:ext cx="2560320" cy="676656"/>
+          </a:xfrm>
+          <a:prstGeom prst="rect">
+            <a:avLst/>
+          </a:prstGeom>
+          <a:noFill/>
+        </p:spPr>
+        <p:txBody>
+          <a:bodyPr wrap="square" anchor="ctr" lIns="0" rIns="0" tIns="0" bIns="0">
+            <a:spAutoFit/>
+          </a:bodyPr>
+          <a:lstStyle/>
+          <a:p>
+            <a:pPr algn="l">
+              <a:lnSpc>
+                <a:spcPct val="104000"/>
+              </a:lnSpc>
+            </a:pPr>
+            <a:r>
+              <a:rPr sz="1250" b="0" i="0">
+                <a:solidFill>
+                  <a:srgbClr val="6B7280"/>
+                </a:solidFill>
+                <a:latin typeface="Trebuchet MS"/>
+              </a:rPr>
+              <a:t>Источники — да; но Запад не стал главным</a:t>
+            </a:r>
+          </a:p>
+        </p:txBody>
+      </p:sp>
+      <p:sp>
+        <p:nvSpPr>
+          <p:cNvPr id="15" name="Rounded Rectangle 14"/>
           <p:cNvSpPr/>
           <p:nvPr/>
         </p:nvSpPr>
         <p:spPr>
           <a:xfrm>
-            <a:off x="868680" y="5532120"/>
-            <a:ext cx="365760" cy="365760"/>
-          </a:xfrm>
-          <a:prstGeom prst="ellipse">
-            <a:avLst/>
+            <a:off x="9098280" y="2642616"/>
+            <a:ext cx="2103120" cy="457200"/>
+          </a:xfrm>
+          <a:prstGeom prst="roundRect">
+            <a:avLst>
+              <a:gd name="adj" fmla="val 35000"/>
+            </a:avLst>
           </a:prstGeom>
           <a:solidFill>
-            <a:srgbClr val="D7263D"/>
+            <a:srgbClr val="2E7D32"/>
           </a:solidFill>
           <a:ln>
             <a:noFill/>
@@ -5728,14 +5836,1045 @@
       </p:sp>
       <p:sp>
         <p:nvSpPr>
-          <p:cNvPr id="13" name="TextBox 12"/>
-          <p:cNvSpPr txBox="1"/>
-          <p:nvPr/>
-        </p:nvSpPr>
-        <p:spPr>
-          <a:xfrm>
-            <a:off x="1463040" y="5440680"/>
-            <a:ext cx="9692640" cy="457200"/>
+          <p:cNvPr id="16" name="TextBox 15"/>
+          <p:cNvSpPr txBox="1"/>
+          <p:nvPr/>
+        </p:nvSpPr>
+        <p:spPr>
+          <a:xfrm>
+            <a:off x="9098280" y="2642616"/>
+            <a:ext cx="2103120" cy="457200"/>
+          </a:xfrm>
+          <a:prstGeom prst="rect">
+            <a:avLst/>
+          </a:prstGeom>
+          <a:noFill/>
+        </p:spPr>
+        <p:txBody>
+          <a:bodyPr wrap="square" anchor="ctr" lIns="0" rIns="0" tIns="0" bIns="0">
+            <a:spAutoFit/>
+          </a:bodyPr>
+          <a:lstStyle/>
+          <a:p>
+            <a:pPr algn="ctr">
+              <a:lnSpc>
+                <a:spcPct val="100000"/>
+              </a:lnSpc>
+            </a:pPr>
+            <a:r>
+              <a:rPr sz="1250" b="1" i="0">
+                <a:solidFill>
+                  <a:srgbClr val="FFFFFF"/>
+                </a:solidFill>
+                <a:latin typeface="Trebuchet MS"/>
+              </a:rPr>
+              <a:t>Подтвердилось</a:t>
+            </a:r>
+          </a:p>
+        </p:txBody>
+      </p:sp>
+      <p:sp>
+        <p:nvSpPr>
+          <p:cNvPr id="17" name="Rounded Rectangle 16"/>
+          <p:cNvSpPr/>
+          <p:nvPr/>
+        </p:nvSpPr>
+        <p:spPr>
+          <a:xfrm>
+            <a:off x="822960" y="3282696"/>
+            <a:ext cx="10515600" cy="676656"/>
+          </a:xfrm>
+          <a:prstGeom prst="roundRect">
+            <a:avLst>
+              <a:gd name="adj" fmla="val 8000"/>
+            </a:avLst>
+          </a:prstGeom>
+          <a:solidFill>
+            <a:srgbClr val="F4F6FB"/>
+          </a:solidFill>
+          <a:ln>
+            <a:noFill/>
+          </a:ln>
+          <a:effectLst/>
+        </p:spPr>
+        <p:style>
+          <a:lnRef idx="1">
+            <a:schemeClr val="accent1"/>
+          </a:lnRef>
+          <a:fillRef idx="3">
+            <a:schemeClr val="accent1"/>
+          </a:fillRef>
+          <a:effectRef idx="2">
+            <a:schemeClr val="accent1"/>
+          </a:effectRef>
+          <a:fontRef idx="minor">
+            <a:schemeClr val="lt1"/>
+          </a:fontRef>
+        </p:style>
+        <p:txBody>
+          <a:bodyPr rtlCol="0" anchor="ctr"/>
+          <a:lstStyle/>
+          <a:p>
+            <a:pPr algn="ctr"/>
+          </a:p>
+        </p:txBody>
+      </p:sp>
+      <p:sp>
+        <p:nvSpPr>
+          <p:cNvPr id="18" name="TextBox 17"/>
+          <p:cNvSpPr txBox="1"/>
+          <p:nvPr/>
+        </p:nvSpPr>
+        <p:spPr>
+          <a:xfrm>
+            <a:off x="1005840" y="3282696"/>
+            <a:ext cx="685800" cy="676656"/>
+          </a:xfrm>
+          <a:prstGeom prst="rect">
+            <a:avLst/>
+          </a:prstGeom>
+          <a:noFill/>
+        </p:spPr>
+        <p:txBody>
+          <a:bodyPr wrap="square" anchor="ctr" lIns="0" rIns="0" tIns="0" bIns="0">
+            <a:spAutoFit/>
+          </a:bodyPr>
+          <a:lstStyle/>
+          <a:p>
+            <a:pPr algn="l">
+              <a:lnSpc>
+                <a:spcPct val="100000"/>
+              </a:lnSpc>
+            </a:pPr>
+            <a:r>
+              <a:rPr sz="1800" b="1" i="0">
+                <a:solidFill>
+                  <a:srgbClr val="1E2761"/>
+                </a:solidFill>
+                <a:latin typeface="Georgia"/>
+              </a:rPr>
+              <a:t>H3</a:t>
+            </a:r>
+          </a:p>
+        </p:txBody>
+      </p:sp>
+      <p:sp>
+        <p:nvSpPr>
+          <p:cNvPr id="19" name="TextBox 18"/>
+          <p:cNvSpPr txBox="1"/>
+          <p:nvPr/>
+        </p:nvSpPr>
+        <p:spPr>
+          <a:xfrm>
+            <a:off x="1737360" y="3282696"/>
+            <a:ext cx="4526280" cy="676656"/>
+          </a:xfrm>
+          <a:prstGeom prst="rect">
+            <a:avLst/>
+          </a:prstGeom>
+          <a:noFill/>
+        </p:spPr>
+        <p:txBody>
+          <a:bodyPr wrap="square" anchor="ctr" lIns="0" rIns="0" tIns="0" bIns="0">
+            <a:spAutoFit/>
+          </a:bodyPr>
+          <a:lstStyle/>
+          <a:p>
+            <a:pPr algn="l">
+              <a:lnSpc>
+                <a:spcPct val="104000"/>
+              </a:lnSpc>
+            </a:pPr>
+            <a:r>
+              <a:rPr sz="1350" b="0" i="0">
+                <a:solidFill>
+                  <a:srgbClr val="1F2937"/>
+                </a:solidFill>
+                <a:latin typeface="Trebuchet MS"/>
+              </a:rPr>
+              <a:t>Поиск делает западные модели «более западными» по содержанию</a:t>
+            </a:r>
+          </a:p>
+        </p:txBody>
+      </p:sp>
+      <p:sp>
+        <p:nvSpPr>
+          <p:cNvPr id="20" name="TextBox 19"/>
+          <p:cNvSpPr txBox="1"/>
+          <p:nvPr/>
+        </p:nvSpPr>
+        <p:spPr>
+          <a:xfrm>
+            <a:off x="6400800" y="3282696"/>
+            <a:ext cx="2560320" cy="676656"/>
+          </a:xfrm>
+          <a:prstGeom prst="rect">
+            <a:avLst/>
+          </a:prstGeom>
+          <a:noFill/>
+        </p:spPr>
+        <p:txBody>
+          <a:bodyPr wrap="square" anchor="ctr" lIns="0" rIns="0" tIns="0" bIns="0">
+            <a:spAutoFit/>
+          </a:bodyPr>
+          <a:lstStyle/>
+          <a:p>
+            <a:pPr algn="l">
+              <a:lnSpc>
+                <a:spcPct val="104000"/>
+              </a:lnSpc>
+            </a:pPr>
+            <a:r>
+              <a:rPr sz="1250" b="0" i="0">
+                <a:solidFill>
+                  <a:srgbClr val="6B7280"/>
+                </a:solidFill>
+                <a:latin typeface="Trebuchet MS"/>
+              </a:rPr>
+              <a:t>Источники сместились, выводы — почти нет</a:t>
+            </a:r>
+          </a:p>
+        </p:txBody>
+      </p:sp>
+      <p:sp>
+        <p:nvSpPr>
+          <p:cNvPr id="21" name="Rounded Rectangle 20"/>
+          <p:cNvSpPr/>
+          <p:nvPr/>
+        </p:nvSpPr>
+        <p:spPr>
+          <a:xfrm>
+            <a:off x="9098280" y="3392424"/>
+            <a:ext cx="2103120" cy="457200"/>
+          </a:xfrm>
+          <a:prstGeom prst="roundRect">
+            <a:avLst>
+              <a:gd name="adj" fmla="val 35000"/>
+            </a:avLst>
+          </a:prstGeom>
+          <a:solidFill>
+            <a:srgbClr val="B02A37"/>
+          </a:solidFill>
+          <a:ln>
+            <a:noFill/>
+          </a:ln>
+          <a:effectLst/>
+        </p:spPr>
+        <p:style>
+          <a:lnRef idx="1">
+            <a:schemeClr val="accent1"/>
+          </a:lnRef>
+          <a:fillRef idx="3">
+            <a:schemeClr val="accent1"/>
+          </a:fillRef>
+          <a:effectRef idx="2">
+            <a:schemeClr val="accent1"/>
+          </a:effectRef>
+          <a:fontRef idx="minor">
+            <a:schemeClr val="lt1"/>
+          </a:fontRef>
+        </p:style>
+        <p:txBody>
+          <a:bodyPr rtlCol="0" anchor="ctr"/>
+          <a:lstStyle/>
+          <a:p>
+            <a:pPr algn="ctr"/>
+          </a:p>
+        </p:txBody>
+      </p:sp>
+      <p:sp>
+        <p:nvSpPr>
+          <p:cNvPr id="22" name="TextBox 21"/>
+          <p:cNvSpPr txBox="1"/>
+          <p:nvPr/>
+        </p:nvSpPr>
+        <p:spPr>
+          <a:xfrm>
+            <a:off x="9098280" y="3392424"/>
+            <a:ext cx="2103120" cy="457200"/>
+          </a:xfrm>
+          <a:prstGeom prst="rect">
+            <a:avLst/>
+          </a:prstGeom>
+          <a:noFill/>
+        </p:spPr>
+        <p:txBody>
+          <a:bodyPr wrap="square" anchor="ctr" lIns="0" rIns="0" tIns="0" bIns="0">
+            <a:spAutoFit/>
+          </a:bodyPr>
+          <a:lstStyle/>
+          <a:p>
+            <a:pPr algn="ctr">
+              <a:lnSpc>
+                <a:spcPct val="100000"/>
+              </a:lnSpc>
+            </a:pPr>
+            <a:r>
+              <a:rPr sz="1250" b="1" i="0">
+                <a:solidFill>
+                  <a:srgbClr val="FFFFFF"/>
+                </a:solidFill>
+                <a:latin typeface="Trebuchet MS"/>
+              </a:rPr>
+              <a:t>Не подтвердилось</a:t>
+            </a:r>
+          </a:p>
+        </p:txBody>
+      </p:sp>
+      <p:sp>
+        <p:nvSpPr>
+          <p:cNvPr id="23" name="Rounded Rectangle 22"/>
+          <p:cNvSpPr/>
+          <p:nvPr/>
+        </p:nvSpPr>
+        <p:spPr>
+          <a:xfrm>
+            <a:off x="822960" y="4032504"/>
+            <a:ext cx="10515600" cy="676656"/>
+          </a:xfrm>
+          <a:prstGeom prst="roundRect">
+            <a:avLst>
+              <a:gd name="adj" fmla="val 8000"/>
+            </a:avLst>
+          </a:prstGeom>
+          <a:solidFill>
+            <a:srgbClr val="F4F6FB"/>
+          </a:solidFill>
+          <a:ln>
+            <a:noFill/>
+          </a:ln>
+          <a:effectLst/>
+        </p:spPr>
+        <p:style>
+          <a:lnRef idx="1">
+            <a:schemeClr val="accent1"/>
+          </a:lnRef>
+          <a:fillRef idx="3">
+            <a:schemeClr val="accent1"/>
+          </a:fillRef>
+          <a:effectRef idx="2">
+            <a:schemeClr val="accent1"/>
+          </a:effectRef>
+          <a:fontRef idx="minor">
+            <a:schemeClr val="lt1"/>
+          </a:fontRef>
+        </p:style>
+        <p:txBody>
+          <a:bodyPr rtlCol="0" anchor="ctr"/>
+          <a:lstStyle/>
+          <a:p>
+            <a:pPr algn="ctr"/>
+          </a:p>
+        </p:txBody>
+      </p:sp>
+      <p:sp>
+        <p:nvSpPr>
+          <p:cNvPr id="24" name="TextBox 23"/>
+          <p:cNvSpPr txBox="1"/>
+          <p:nvPr/>
+        </p:nvSpPr>
+        <p:spPr>
+          <a:xfrm>
+            <a:off x="1005840" y="4032504"/>
+            <a:ext cx="685800" cy="676656"/>
+          </a:xfrm>
+          <a:prstGeom prst="rect">
+            <a:avLst/>
+          </a:prstGeom>
+          <a:noFill/>
+        </p:spPr>
+        <p:txBody>
+          <a:bodyPr wrap="square" anchor="ctr" lIns="0" rIns="0" tIns="0" bIns="0">
+            <a:spAutoFit/>
+          </a:bodyPr>
+          <a:lstStyle/>
+          <a:p>
+            <a:pPr algn="l">
+              <a:lnSpc>
+                <a:spcPct val="100000"/>
+              </a:lnSpc>
+            </a:pPr>
+            <a:r>
+              <a:rPr sz="1800" b="1" i="0">
+                <a:solidFill>
+                  <a:srgbClr val="1E2761"/>
+                </a:solidFill>
+                <a:latin typeface="Georgia"/>
+              </a:rPr>
+              <a:t>H4</a:t>
+            </a:r>
+          </a:p>
+        </p:txBody>
+      </p:sp>
+      <p:sp>
+        <p:nvSpPr>
+          <p:cNvPr id="25" name="TextBox 24"/>
+          <p:cNvSpPr txBox="1"/>
+          <p:nvPr/>
+        </p:nvSpPr>
+        <p:spPr>
+          <a:xfrm>
+            <a:off x="1737360" y="4032504"/>
+            <a:ext cx="4526280" cy="676656"/>
+          </a:xfrm>
+          <a:prstGeom prst="rect">
+            <a:avLst/>
+          </a:prstGeom>
+          <a:noFill/>
+        </p:spPr>
+        <p:txBody>
+          <a:bodyPr wrap="square" anchor="ctr" lIns="0" rIns="0" tIns="0" bIns="0">
+            <a:spAutoFit/>
+          </a:bodyPr>
+          <a:lstStyle/>
+          <a:p>
+            <a:pPr algn="l">
+              <a:lnSpc>
+                <a:spcPct val="104000"/>
+              </a:lnSpc>
+            </a:pPr>
+            <a:r>
+              <a:rPr sz="1350" b="0" i="0">
+                <a:solidFill>
+                  <a:srgbClr val="1F2937"/>
+                </a:solidFill>
+                <a:latin typeface="Trebuchet MS"/>
+              </a:rPr>
+              <a:t>Повторные прогоны дадут сильный разброс ответов</a:t>
+            </a:r>
+          </a:p>
+        </p:txBody>
+      </p:sp>
+      <p:sp>
+        <p:nvSpPr>
+          <p:cNvPr id="26" name="TextBox 25"/>
+          <p:cNvSpPr txBox="1"/>
+          <p:nvPr/>
+        </p:nvSpPr>
+        <p:spPr>
+          <a:xfrm>
+            <a:off x="6400800" y="4032504"/>
+            <a:ext cx="2560320" cy="676656"/>
+          </a:xfrm>
+          <a:prstGeom prst="rect">
+            <a:avLst/>
+          </a:prstGeom>
+          <a:noFill/>
+        </p:spPr>
+        <p:txBody>
+          <a:bodyPr wrap="square" anchor="ctr" lIns="0" rIns="0" tIns="0" bIns="0">
+            <a:spAutoFit/>
+          </a:bodyPr>
+          <a:lstStyle/>
+          <a:p>
+            <a:pPr algn="l">
+              <a:lnSpc>
+                <a:spcPct val="104000"/>
+              </a:lnSpc>
+            </a:pPr>
+            <a:r>
+              <a:rPr sz="1250" b="0" i="0">
+                <a:solidFill>
+                  <a:srgbClr val="6B7280"/>
+                </a:solidFill>
+                <a:latin typeface="Trebuchet MS"/>
+              </a:rPr>
+              <a:t>Три прогона Grok совпали до десятых</a:t>
+            </a:r>
+          </a:p>
+        </p:txBody>
+      </p:sp>
+      <p:sp>
+        <p:nvSpPr>
+          <p:cNvPr id="27" name="Rounded Rectangle 26"/>
+          <p:cNvSpPr/>
+          <p:nvPr/>
+        </p:nvSpPr>
+        <p:spPr>
+          <a:xfrm>
+            <a:off x="9098280" y="4142232"/>
+            <a:ext cx="2103120" cy="457200"/>
+          </a:xfrm>
+          <a:prstGeom prst="roundRect">
+            <a:avLst>
+              <a:gd name="adj" fmla="val 35000"/>
+            </a:avLst>
+          </a:prstGeom>
+          <a:solidFill>
+            <a:srgbClr val="B02A37"/>
+          </a:solidFill>
+          <a:ln>
+            <a:noFill/>
+          </a:ln>
+          <a:effectLst/>
+        </p:spPr>
+        <p:style>
+          <a:lnRef idx="1">
+            <a:schemeClr val="accent1"/>
+          </a:lnRef>
+          <a:fillRef idx="3">
+            <a:schemeClr val="accent1"/>
+          </a:fillRef>
+          <a:effectRef idx="2">
+            <a:schemeClr val="accent1"/>
+          </a:effectRef>
+          <a:fontRef idx="minor">
+            <a:schemeClr val="lt1"/>
+          </a:fontRef>
+        </p:style>
+        <p:txBody>
+          <a:bodyPr rtlCol="0" anchor="ctr"/>
+          <a:lstStyle/>
+          <a:p>
+            <a:pPr algn="ctr"/>
+          </a:p>
+        </p:txBody>
+      </p:sp>
+      <p:sp>
+        <p:nvSpPr>
+          <p:cNvPr id="28" name="TextBox 27"/>
+          <p:cNvSpPr txBox="1"/>
+          <p:nvPr/>
+        </p:nvSpPr>
+        <p:spPr>
+          <a:xfrm>
+            <a:off x="9098280" y="4142232"/>
+            <a:ext cx="2103120" cy="457200"/>
+          </a:xfrm>
+          <a:prstGeom prst="rect">
+            <a:avLst/>
+          </a:prstGeom>
+          <a:noFill/>
+        </p:spPr>
+        <p:txBody>
+          <a:bodyPr wrap="square" anchor="ctr" lIns="0" rIns="0" tIns="0" bIns="0">
+            <a:spAutoFit/>
+          </a:bodyPr>
+          <a:lstStyle/>
+          <a:p>
+            <a:pPr algn="ctr">
+              <a:lnSpc>
+                <a:spcPct val="100000"/>
+              </a:lnSpc>
+            </a:pPr>
+            <a:r>
+              <a:rPr sz="1250" b="1" i="0">
+                <a:solidFill>
+                  <a:srgbClr val="FFFFFF"/>
+                </a:solidFill>
+                <a:latin typeface="Trebuchet MS"/>
+              </a:rPr>
+              <a:t>Не подтвердилось</a:t>
+            </a:r>
+          </a:p>
+        </p:txBody>
+      </p:sp>
+      <p:sp>
+        <p:nvSpPr>
+          <p:cNvPr id="29" name="Rounded Rectangle 28"/>
+          <p:cNvSpPr/>
+          <p:nvPr/>
+        </p:nvSpPr>
+        <p:spPr>
+          <a:xfrm>
+            <a:off x="822960" y="4782312"/>
+            <a:ext cx="10515600" cy="676656"/>
+          </a:xfrm>
+          <a:prstGeom prst="roundRect">
+            <a:avLst>
+              <a:gd name="adj" fmla="val 8000"/>
+            </a:avLst>
+          </a:prstGeom>
+          <a:solidFill>
+            <a:srgbClr val="F4F6FB"/>
+          </a:solidFill>
+          <a:ln>
+            <a:noFill/>
+          </a:ln>
+          <a:effectLst/>
+        </p:spPr>
+        <p:style>
+          <a:lnRef idx="1">
+            <a:schemeClr val="accent1"/>
+          </a:lnRef>
+          <a:fillRef idx="3">
+            <a:schemeClr val="accent1"/>
+          </a:fillRef>
+          <a:effectRef idx="2">
+            <a:schemeClr val="accent1"/>
+          </a:effectRef>
+          <a:fontRef idx="minor">
+            <a:schemeClr val="lt1"/>
+          </a:fontRef>
+        </p:style>
+        <p:txBody>
+          <a:bodyPr rtlCol="0" anchor="ctr"/>
+          <a:lstStyle/>
+          <a:p>
+            <a:pPr algn="ctr"/>
+          </a:p>
+        </p:txBody>
+      </p:sp>
+      <p:sp>
+        <p:nvSpPr>
+          <p:cNvPr id="30" name="TextBox 29"/>
+          <p:cNvSpPr txBox="1"/>
+          <p:nvPr/>
+        </p:nvSpPr>
+        <p:spPr>
+          <a:xfrm>
+            <a:off x="1005840" y="4782312"/>
+            <a:ext cx="685800" cy="676656"/>
+          </a:xfrm>
+          <a:prstGeom prst="rect">
+            <a:avLst/>
+          </a:prstGeom>
+          <a:noFill/>
+        </p:spPr>
+        <p:txBody>
+          <a:bodyPr wrap="square" anchor="ctr" lIns="0" rIns="0" tIns="0" bIns="0">
+            <a:spAutoFit/>
+          </a:bodyPr>
+          <a:lstStyle/>
+          <a:p>
+            <a:pPr algn="l">
+              <a:lnSpc>
+                <a:spcPct val="100000"/>
+              </a:lnSpc>
+            </a:pPr>
+            <a:r>
+              <a:rPr sz="1800" b="1" i="0">
+                <a:solidFill>
+                  <a:srgbClr val="1E2761"/>
+                </a:solidFill>
+                <a:latin typeface="Georgia"/>
+              </a:rPr>
+              <a:t>H5</a:t>
+            </a:r>
+          </a:p>
+        </p:txBody>
+      </p:sp>
+      <p:sp>
+        <p:nvSpPr>
+          <p:cNvPr id="31" name="TextBox 30"/>
+          <p:cNvSpPr txBox="1"/>
+          <p:nvPr/>
+        </p:nvSpPr>
+        <p:spPr>
+          <a:xfrm>
+            <a:off x="1737360" y="4782312"/>
+            <a:ext cx="4526280" cy="676656"/>
+          </a:xfrm>
+          <a:prstGeom prst="rect">
+            <a:avLst/>
+          </a:prstGeom>
+          <a:noFill/>
+        </p:spPr>
+        <p:txBody>
+          <a:bodyPr wrap="square" anchor="ctr" lIns="0" rIns="0" tIns="0" bIns="0">
+            <a:spAutoFit/>
+          </a:bodyPr>
+          <a:lstStyle/>
+          <a:p>
+            <a:pPr algn="l">
+              <a:lnSpc>
+                <a:spcPct val="104000"/>
+              </a:lnSpc>
+            </a:pPr>
+            <a:r>
+              <a:rPr sz="1350" b="0" i="0">
+                <a:solidFill>
+                  <a:srgbClr val="1F2937"/>
+                </a:solidFill>
+                <a:latin typeface="Trebuchet MS"/>
+              </a:rPr>
+              <a:t>Культурный bias = устойчивый раскол «Россия vs Запад»</a:t>
+            </a:r>
+          </a:p>
+        </p:txBody>
+      </p:sp>
+      <p:sp>
+        <p:nvSpPr>
+          <p:cNvPr id="32" name="TextBox 31"/>
+          <p:cNvSpPr txBox="1"/>
+          <p:nvPr/>
+        </p:nvSpPr>
+        <p:spPr>
+          <a:xfrm>
+            <a:off x="6400800" y="4782312"/>
+            <a:ext cx="2560320" cy="676656"/>
+          </a:xfrm>
+          <a:prstGeom prst="rect">
+            <a:avLst/>
+          </a:prstGeom>
+          <a:noFill/>
+        </p:spPr>
+        <p:txBody>
+          <a:bodyPr wrap="square" anchor="ctr" lIns="0" rIns="0" tIns="0" bIns="0">
+            <a:spAutoFit/>
+          </a:bodyPr>
+          <a:lstStyle/>
+          <a:p>
+            <a:pPr algn="l">
+              <a:lnSpc>
+                <a:spcPct val="104000"/>
+              </a:lnSpc>
+            </a:pPr>
+            <a:r>
+              <a:rPr sz="1250" b="0" i="0">
+                <a:solidFill>
+                  <a:srgbClr val="6B7280"/>
+                </a:solidFill>
+                <a:latin typeface="Trebuchet MS"/>
+              </a:rPr>
+              <a:t>Раскол в риторике и источниках, не в причинах</a:t>
+            </a:r>
+          </a:p>
+        </p:txBody>
+      </p:sp>
+      <p:sp>
+        <p:nvSpPr>
+          <p:cNvPr id="33" name="Rounded Rectangle 32"/>
+          <p:cNvSpPr/>
+          <p:nvPr/>
+        </p:nvSpPr>
+        <p:spPr>
+          <a:xfrm>
+            <a:off x="9098280" y="4892040"/>
+            <a:ext cx="2103120" cy="457200"/>
+          </a:xfrm>
+          <a:prstGeom prst="roundRect">
+            <a:avLst>
+              <a:gd name="adj" fmla="val 35000"/>
+            </a:avLst>
+          </a:prstGeom>
+          <a:solidFill>
+            <a:srgbClr val="B56A00"/>
+          </a:solidFill>
+          <a:ln>
+            <a:noFill/>
+          </a:ln>
+          <a:effectLst/>
+        </p:spPr>
+        <p:style>
+          <a:lnRef idx="1">
+            <a:schemeClr val="accent1"/>
+          </a:lnRef>
+          <a:fillRef idx="3">
+            <a:schemeClr val="accent1"/>
+          </a:fillRef>
+          <a:effectRef idx="2">
+            <a:schemeClr val="accent1"/>
+          </a:effectRef>
+          <a:fontRef idx="minor">
+            <a:schemeClr val="lt1"/>
+          </a:fontRef>
+        </p:style>
+        <p:txBody>
+          <a:bodyPr rtlCol="0" anchor="ctr"/>
+          <a:lstStyle/>
+          <a:p>
+            <a:pPr algn="ctr"/>
+          </a:p>
+        </p:txBody>
+      </p:sp>
+      <p:sp>
+        <p:nvSpPr>
+          <p:cNvPr id="34" name="TextBox 33"/>
+          <p:cNvSpPr txBox="1"/>
+          <p:nvPr/>
+        </p:nvSpPr>
+        <p:spPr>
+          <a:xfrm>
+            <a:off x="9098280" y="4892040"/>
+            <a:ext cx="2103120" cy="457200"/>
+          </a:xfrm>
+          <a:prstGeom prst="rect">
+            <a:avLst/>
+          </a:prstGeom>
+          <a:noFill/>
+        </p:spPr>
+        <p:txBody>
+          <a:bodyPr wrap="square" anchor="ctr" lIns="0" rIns="0" tIns="0" bIns="0">
+            <a:spAutoFit/>
+          </a:bodyPr>
+          <a:lstStyle/>
+          <a:p>
+            <a:pPr algn="ctr">
+              <a:lnSpc>
+                <a:spcPct val="100000"/>
+              </a:lnSpc>
+            </a:pPr>
+            <a:r>
+              <a:rPr sz="1250" b="1" i="0">
+                <a:solidFill>
+                  <a:srgbClr val="FFFFFF"/>
+                </a:solidFill>
+                <a:latin typeface="Trebuchet MS"/>
+              </a:rPr>
+              <a:t>Частично</a:t>
+            </a:r>
+          </a:p>
+        </p:txBody>
+      </p:sp>
+      <p:sp>
+        <p:nvSpPr>
+          <p:cNvPr id="35" name="Rounded Rectangle 34"/>
+          <p:cNvSpPr/>
+          <p:nvPr/>
+        </p:nvSpPr>
+        <p:spPr>
+          <a:xfrm>
+            <a:off x="822960" y="5532120"/>
+            <a:ext cx="10515600" cy="676656"/>
+          </a:xfrm>
+          <a:prstGeom prst="roundRect">
+            <a:avLst>
+              <a:gd name="adj" fmla="val 8000"/>
+            </a:avLst>
+          </a:prstGeom>
+          <a:solidFill>
+            <a:srgbClr val="F4F6FB"/>
+          </a:solidFill>
+          <a:ln>
+            <a:noFill/>
+          </a:ln>
+          <a:effectLst/>
+        </p:spPr>
+        <p:style>
+          <a:lnRef idx="1">
+            <a:schemeClr val="accent1"/>
+          </a:lnRef>
+          <a:fillRef idx="3">
+            <a:schemeClr val="accent1"/>
+          </a:fillRef>
+          <a:effectRef idx="2">
+            <a:schemeClr val="accent1"/>
+          </a:effectRef>
+          <a:fontRef idx="minor">
+            <a:schemeClr val="lt1"/>
+          </a:fontRef>
+        </p:style>
+        <p:txBody>
+          <a:bodyPr rtlCol="0" anchor="ctr"/>
+          <a:lstStyle/>
+          <a:p>
+            <a:pPr algn="ctr"/>
+          </a:p>
+        </p:txBody>
+      </p:sp>
+      <p:sp>
+        <p:nvSpPr>
+          <p:cNvPr id="36" name="TextBox 35"/>
+          <p:cNvSpPr txBox="1"/>
+          <p:nvPr/>
+        </p:nvSpPr>
+        <p:spPr>
+          <a:xfrm>
+            <a:off x="1005840" y="5532120"/>
+            <a:ext cx="685800" cy="676656"/>
+          </a:xfrm>
+          <a:prstGeom prst="rect">
+            <a:avLst/>
+          </a:prstGeom>
+          <a:noFill/>
+        </p:spPr>
+        <p:txBody>
+          <a:bodyPr wrap="square" anchor="ctr" lIns="0" rIns="0" tIns="0" bIns="0">
+            <a:spAutoFit/>
+          </a:bodyPr>
+          <a:lstStyle/>
+          <a:p>
+            <a:pPr algn="l">
+              <a:lnSpc>
+                <a:spcPct val="100000"/>
+              </a:lnSpc>
+            </a:pPr>
+            <a:r>
+              <a:rPr sz="1800" b="1" i="0">
+                <a:solidFill>
+                  <a:srgbClr val="1E2761"/>
+                </a:solidFill>
+                <a:latin typeface="Georgia"/>
+              </a:rPr>
+              <a:t>H6</a:t>
+            </a:r>
+          </a:p>
+        </p:txBody>
+      </p:sp>
+      <p:sp>
+        <p:nvSpPr>
+          <p:cNvPr id="37" name="TextBox 36"/>
+          <p:cNvSpPr txBox="1"/>
+          <p:nvPr/>
+        </p:nvSpPr>
+        <p:spPr>
+          <a:xfrm>
+            <a:off x="1737360" y="5532120"/>
+            <a:ext cx="4526280" cy="676656"/>
+          </a:xfrm>
+          <a:prstGeom prst="rect">
+            <a:avLst/>
+          </a:prstGeom>
+          <a:noFill/>
+        </p:spPr>
+        <p:txBody>
+          <a:bodyPr wrap="square" anchor="ctr" lIns="0" rIns="0" tIns="0" bIns="0">
+            <a:spAutoFit/>
+          </a:bodyPr>
+          <a:lstStyle/>
+          <a:p>
+            <a:pPr algn="l">
+              <a:lnSpc>
+                <a:spcPct val="104000"/>
+              </a:lnSpc>
+            </a:pPr>
+            <a:r>
+              <a:rPr sz="1350" b="0" i="0">
+                <a:solidFill>
+                  <a:srgbClr val="1F2937"/>
+                </a:solidFill>
+                <a:latin typeface="Trebuchet MS"/>
+              </a:rPr>
+              <a:t>DeepSeek нейтральнее; с поиском сближается с западными</a:t>
+            </a:r>
+          </a:p>
+        </p:txBody>
+      </p:sp>
+      <p:sp>
+        <p:nvSpPr>
+          <p:cNvPr id="38" name="TextBox 37"/>
+          <p:cNvSpPr txBox="1"/>
+          <p:nvPr/>
+        </p:nvSpPr>
+        <p:spPr>
+          <a:xfrm>
+            <a:off x="6400800" y="5532120"/>
+            <a:ext cx="2560320" cy="676656"/>
+          </a:xfrm>
+          <a:prstGeom prst="rect">
+            <a:avLst/>
+          </a:prstGeom>
+          <a:noFill/>
+        </p:spPr>
+        <p:txBody>
+          <a:bodyPr wrap="square" anchor="ctr" lIns="0" rIns="0" tIns="0" bIns="0">
+            <a:spAutoFit/>
+          </a:bodyPr>
+          <a:lstStyle/>
+          <a:p>
+            <a:pPr algn="l">
+              <a:lnSpc>
+                <a:spcPct val="104000"/>
+              </a:lnSpc>
+            </a:pPr>
+            <a:r>
+              <a:rPr sz="1250" b="0" i="0">
+                <a:solidFill>
+                  <a:srgbClr val="6B7280"/>
+                </a:solidFill>
+                <a:latin typeface="Trebuchet MS"/>
+              </a:rPr>
+              <a:t>Сухой и нейтральный; эффект поиска мал</a:t>
+            </a:r>
+          </a:p>
+        </p:txBody>
+      </p:sp>
+      <p:sp>
+        <p:nvSpPr>
+          <p:cNvPr id="39" name="Rounded Rectangle 38"/>
+          <p:cNvSpPr/>
+          <p:nvPr/>
+        </p:nvSpPr>
+        <p:spPr>
+          <a:xfrm>
+            <a:off x="9098280" y="5641848"/>
+            <a:ext cx="2103120" cy="457200"/>
+          </a:xfrm>
+          <a:prstGeom prst="roundRect">
+            <a:avLst>
+              <a:gd name="adj" fmla="val 35000"/>
+            </a:avLst>
+          </a:prstGeom>
+          <a:solidFill>
+            <a:srgbClr val="2E7D32"/>
+          </a:solidFill>
+          <a:ln>
+            <a:noFill/>
+          </a:ln>
+          <a:effectLst/>
+        </p:spPr>
+        <p:style>
+          <a:lnRef idx="1">
+            <a:schemeClr val="accent1"/>
+          </a:lnRef>
+          <a:fillRef idx="3">
+            <a:schemeClr val="accent1"/>
+          </a:fillRef>
+          <a:effectRef idx="2">
+            <a:schemeClr val="accent1"/>
+          </a:effectRef>
+          <a:fontRef idx="minor">
+            <a:schemeClr val="lt1"/>
+          </a:fontRef>
+        </p:style>
+        <p:txBody>
+          <a:bodyPr rtlCol="0" anchor="ctr"/>
+          <a:lstStyle/>
+          <a:p>
+            <a:pPr algn="ctr"/>
+          </a:p>
+        </p:txBody>
+      </p:sp>
+      <p:sp>
+        <p:nvSpPr>
+          <p:cNvPr id="40" name="TextBox 39"/>
+          <p:cNvSpPr txBox="1"/>
+          <p:nvPr/>
+        </p:nvSpPr>
+        <p:spPr>
+          <a:xfrm>
+            <a:off x="9098280" y="5641848"/>
+            <a:ext cx="2103120" cy="457200"/>
+          </a:xfrm>
+          <a:prstGeom prst="rect">
+            <a:avLst/>
+          </a:prstGeom>
+          <a:noFill/>
+        </p:spPr>
+        <p:txBody>
+          <a:bodyPr wrap="square" anchor="ctr" lIns="0" rIns="0" tIns="0" bIns="0">
+            <a:spAutoFit/>
+          </a:bodyPr>
+          <a:lstStyle/>
+          <a:p>
+            <a:pPr algn="ctr">
+              <a:lnSpc>
+                <a:spcPct val="100000"/>
+              </a:lnSpc>
+            </a:pPr>
+            <a:r>
+              <a:rPr sz="1250" b="1" i="0">
+                <a:solidFill>
+                  <a:srgbClr val="FFFFFF"/>
+                </a:solidFill>
+                <a:latin typeface="Trebuchet MS"/>
+              </a:rPr>
+              <a:t>Подтвердилось</a:t>
+            </a:r>
+          </a:p>
+        </p:txBody>
+      </p:sp>
+      <p:sp>
+        <p:nvSpPr>
+          <p:cNvPr id="41" name="TextBox 40"/>
+          <p:cNvSpPr txBox="1"/>
+          <p:nvPr/>
+        </p:nvSpPr>
+        <p:spPr>
+          <a:xfrm>
+            <a:off x="822960" y="6382512"/>
+            <a:ext cx="10058400" cy="365760"/>
           </a:xfrm>
           <a:prstGeom prst="rect">
             <a:avLst/>
@@ -5754,52 +6893,13 @@
               </a:lnSpc>
             </a:pPr>
             <a:r>
-              <a:rPr sz="1800" b="1" i="0">
-                <a:solidFill>
-                  <a:srgbClr val="CADCFC"/>
-                </a:solidFill>
-                <a:latin typeface="Georgia"/>
-              </a:rPr>
-              <a:t>Bias виден в источниках</a:t>
-            </a:r>
-          </a:p>
-        </p:txBody>
-      </p:sp>
-      <p:sp>
-        <p:nvSpPr>
-          <p:cNvPr id="14" name="TextBox 13"/>
-          <p:cNvSpPr txBox="1"/>
-          <p:nvPr/>
-        </p:nvSpPr>
-        <p:spPr>
-          <a:xfrm>
-            <a:off x="1463040" y="5897880"/>
-            <a:ext cx="9692640" cy="502920"/>
-          </a:xfrm>
-          <a:prstGeom prst="rect">
-            <a:avLst/>
-          </a:prstGeom>
-          <a:noFill/>
-        </p:spPr>
-        <p:txBody>
-          <a:bodyPr wrap="square" anchor="t" lIns="0" rIns="0" tIns="0" bIns="0">
-            <a:spAutoFit/>
-          </a:bodyPr>
-          <a:lstStyle/>
-          <a:p>
-            <a:pPr algn="l">
-              <a:lnSpc>
-                <a:spcPct val="110000"/>
-              </a:lnSpc>
-            </a:pPr>
-            <a:r>
-              <a:rPr sz="1500" b="0" i="0">
-                <a:solidFill>
-                  <a:srgbClr val="C8D0E8"/>
+              <a:rPr sz="1200" b="0" i="1">
+                <a:solidFill>
+                  <a:srgbClr val="9CA3AF"/>
                 </a:solidFill>
                 <a:latin typeface="Trebuchet MS"/>
               </a:rPr>
-              <a:t>Региональный сдвиг есть в подборе ссылок — но на итоговую интерпретацию влияет слабо.</a:t>
+              <a:t>Полный разбор по каждой гипотезе — в docs/HYPOTHESES.md.</a:t>
             </a:r>
           </a:p>
         </p:txBody>
@@ -5837,7 +6937,7 @@
             <a:avLst/>
           </a:prstGeom>
           <a:solidFill>
-            <a:srgbClr val="FFFFFF"/>
+            <a:srgbClr val="1E2761"/>
           </a:solidFill>
           <a:ln>
             <a:noFill/>
@@ -5874,7 +6974,7 @@
         </p:nvSpPr>
         <p:spPr>
           <a:xfrm>
-            <a:off x="822960" y="502920"/>
+            <a:off x="822960" y="640080"/>
             <a:ext cx="10515600" cy="640080"/>
           </a:xfrm>
           <a:prstGeom prst="rect">
@@ -5894,13 +6994,13 @@
               </a:lnSpc>
             </a:pPr>
             <a:r>
-              <a:rPr sz="3200" b="1" i="0">
-                <a:solidFill>
-                  <a:srgbClr val="1E2761"/>
+              <a:rPr sz="3400" b="1" i="0">
+                <a:solidFill>
+                  <a:srgbClr val="FFFFFF"/>
                 </a:solidFill>
                 <a:latin typeface="Georgia"/>
               </a:rPr>
-              <a:t>Честные ограничения</a:t>
+              <a:t>Что это значит</a:t>
             </a:r>
           </a:p>
         </p:txBody>
@@ -5913,8 +7013,8 @@
         </p:nvSpPr>
         <p:spPr>
           <a:xfrm>
-            <a:off x="822960" y="1554480"/>
-            <a:ext cx="10515600" cy="1024128"/>
+            <a:off x="822960" y="1645920"/>
+            <a:ext cx="10515600" cy="1554480"/>
           </a:xfrm>
           <a:prstGeom prst="roundRect">
             <a:avLst>
@@ -5922,7 +7022,7 @@
             </a:avLst>
           </a:prstGeom>
           <a:solidFill>
-            <a:srgbClr val="F4F6FB"/>
+            <a:srgbClr val="2B3573"/>
           </a:solidFill>
           <a:ln>
             <a:noFill/>
@@ -5959,8 +7059,8 @@
         </p:nvSpPr>
         <p:spPr>
           <a:xfrm>
-            <a:off x="1143000" y="1700784"/>
-            <a:ext cx="4023360" cy="731520"/>
+            <a:off x="1188720" y="1874519"/>
+            <a:ext cx="9784080" cy="1097280"/>
           </a:xfrm>
           <a:prstGeom prst="rect">
             <a:avLst/>
@@ -5975,78 +7075,53 @@
           <a:p>
             <a:pPr algn="l">
               <a:lnSpc>
-                <a:spcPct val="100000"/>
-              </a:lnSpc>
-            </a:pPr>
-            <a:r>
-              <a:rPr sz="1750" b="1" i="0">
-                <a:solidFill>
-                  <a:srgbClr val="1E2761"/>
+                <a:spcPct val="115000"/>
+              </a:lnSpc>
+            </a:pPr>
+            <a:r>
+              <a:rPr sz="2000" b="1" i="0">
+                <a:solidFill>
+                  <a:srgbClr val="FFFFFF"/>
                 </a:solidFill>
                 <a:latin typeface="Georgia"/>
               </a:rPr>
-              <a:t>Это снимок, а не приговор</a:t>
-            </a:r>
-          </a:p>
-        </p:txBody>
-      </p:sp>
-      <p:sp>
-        <p:nvSpPr>
-          <p:cNvPr id="6" name="TextBox 5"/>
-          <p:cNvSpPr txBox="1"/>
-          <p:nvPr/>
-        </p:nvSpPr>
-        <p:spPr>
-          <a:xfrm>
-            <a:off x="5349240" y="1700784"/>
-            <a:ext cx="5760720" cy="777240"/>
-          </a:xfrm>
-          <a:prstGeom prst="rect">
-            <a:avLst/>
-          </a:prstGeom>
-          <a:noFill/>
-        </p:spPr>
-        <p:txBody>
-          <a:bodyPr wrap="square" anchor="ctr" lIns="0" rIns="0" tIns="0" bIns="0">
-            <a:spAutoFit/>
-          </a:bodyPr>
-          <a:lstStyle/>
-          <a:p>
-            <a:pPr algn="l">
-              <a:lnSpc>
-                <a:spcPct val="112000"/>
-              </a:lnSpc>
-            </a:pPr>
-            <a:r>
-              <a:rPr sz="1450" b="0" i="0">
-                <a:solidFill>
-                  <a:srgbClr val="6B7280"/>
-                </a:solidFill>
-                <a:latin typeface="Trebuchet MS"/>
-              </a:rPr>
-              <a:t>Баллы описывают поведение моделей в конкретных промптах, датах и режимах — не «истину» о модели.</a:t>
-            </a:r>
-          </a:p>
-        </p:txBody>
-      </p:sp>
-      <p:sp>
-        <p:nvSpPr>
-          <p:cNvPr id="7" name="Rounded Rectangle 6"/>
+              <a:t>Культурного раскола «Россия против Запада» в базовой причинности мы не нашли.</a:t>
+            </a:r>
+          </a:p>
+          <a:p>
+            <a:pPr algn="l">
+              <a:lnSpc>
+                <a:spcPct val="115000"/>
+              </a:lnSpc>
+            </a:pPr>
+            <a:r>
+              <a:rPr sz="2000" b="1" i="0">
+                <a:solidFill>
+                  <a:srgbClr val="FFFFFF"/>
+                </a:solidFill>
+                <a:latin typeface="Georgia"/>
+              </a:rPr>
+              <a:t>Главный измеримый разрыв — не между моделями, а между моделями и людьми.</a:t>
+            </a:r>
+          </a:p>
+        </p:txBody>
+      </p:sp>
+      <p:sp>
+        <p:nvSpPr>
+          <p:cNvPr id="6" name="Oval 5"/>
           <p:cNvSpPr/>
           <p:nvPr/>
         </p:nvSpPr>
         <p:spPr>
           <a:xfrm>
-            <a:off x="822960" y="2724912"/>
-            <a:ext cx="10515600" cy="1024128"/>
-          </a:xfrm>
-          <a:prstGeom prst="roundRect">
-            <a:avLst>
-              <a:gd name="adj" fmla="val 8000"/>
-            </a:avLst>
+            <a:off x="868680" y="3611880"/>
+            <a:ext cx="365760" cy="365760"/>
+          </a:xfrm>
+          <a:prstGeom prst="ellipse">
+            <a:avLst/>
           </a:prstGeom>
           <a:solidFill>
-            <a:srgbClr val="F4F6FB"/>
+            <a:srgbClr val="D7263D"/>
           </a:solidFill>
           <a:ln>
             <a:noFill/>
@@ -6077,100 +7152,98 @@
       </p:sp>
       <p:sp>
         <p:nvSpPr>
+          <p:cNvPr id="7" name="TextBox 6"/>
+          <p:cNvSpPr txBox="1"/>
+          <p:nvPr/>
+        </p:nvSpPr>
+        <p:spPr>
+          <a:xfrm>
+            <a:off x="1463040" y="3520440"/>
+            <a:ext cx="9692640" cy="457200"/>
+          </a:xfrm>
+          <a:prstGeom prst="rect">
+            <a:avLst/>
+          </a:prstGeom>
+          <a:noFill/>
+        </p:spPr>
+        <p:txBody>
+          <a:bodyPr wrap="square" anchor="t" lIns="0" rIns="0" tIns="0" bIns="0">
+            <a:spAutoFit/>
+          </a:bodyPr>
+          <a:lstStyle/>
+          <a:p>
+            <a:pPr algn="l">
+              <a:lnSpc>
+                <a:spcPct val="100000"/>
+              </a:lnSpc>
+            </a:pPr>
+            <a:r>
+              <a:rPr sz="1800" b="1" i="0">
+                <a:solidFill>
+                  <a:srgbClr val="CADCFC"/>
+                </a:solidFill>
+                <a:latin typeface="Georgia"/>
+              </a:rPr>
+              <a:t>Консенсус сильнее ожиданий</a:t>
+            </a:r>
+          </a:p>
+        </p:txBody>
+      </p:sp>
+      <p:sp>
+        <p:nvSpPr>
           <p:cNvPr id="8" name="TextBox 7"/>
           <p:cNvSpPr txBox="1"/>
           <p:nvPr/>
         </p:nvSpPr>
         <p:spPr>
           <a:xfrm>
-            <a:off x="1143000" y="2871216"/>
-            <a:ext cx="4023360" cy="731520"/>
-          </a:xfrm>
-          <a:prstGeom prst="rect">
-            <a:avLst/>
-          </a:prstGeom>
-          <a:noFill/>
-        </p:spPr>
-        <p:txBody>
-          <a:bodyPr wrap="square" anchor="ctr" lIns="0" rIns="0" tIns="0" bIns="0">
-            <a:spAutoFit/>
-          </a:bodyPr>
-          <a:lstStyle/>
-          <a:p>
-            <a:pPr algn="l">
-              <a:lnSpc>
-                <a:spcPct val="100000"/>
-              </a:lnSpc>
-            </a:pPr>
-            <a:r>
-              <a:rPr sz="1750" b="1" i="0">
-                <a:solidFill>
-                  <a:srgbClr val="1E2761"/>
-                </a:solidFill>
-                <a:latin typeface="Georgia"/>
-              </a:rPr>
-              <a:t>Субъективность кодировки</a:t>
-            </a:r>
-          </a:p>
-        </p:txBody>
-      </p:sp>
-      <p:sp>
-        <p:nvSpPr>
-          <p:cNvPr id="9" name="TextBox 8"/>
-          <p:cNvSpPr txBox="1"/>
-          <p:nvPr/>
-        </p:nvSpPr>
-        <p:spPr>
-          <a:xfrm>
-            <a:off x="5349240" y="2871216"/>
-            <a:ext cx="5760720" cy="777240"/>
-          </a:xfrm>
-          <a:prstGeom prst="rect">
-            <a:avLst/>
-          </a:prstGeom>
-          <a:noFill/>
-        </p:spPr>
-        <p:txBody>
-          <a:bodyPr wrap="square" anchor="ctr" lIns="0" rIns="0" tIns="0" bIns="0">
-            <a:spAutoFit/>
-          </a:bodyPr>
-          <a:lstStyle/>
-          <a:p>
-            <a:pPr algn="l">
-              <a:lnSpc>
-                <a:spcPct val="112000"/>
-              </a:lnSpc>
-            </a:pPr>
-            <a:r>
-              <a:rPr sz="1450" b="0" i="0">
-                <a:solidFill>
-                  <a:srgbClr val="6B7280"/>
+            <a:off x="1463040" y="3977640"/>
+            <a:ext cx="9692640" cy="502920"/>
+          </a:xfrm>
+          <a:prstGeom prst="rect">
+            <a:avLst/>
+          </a:prstGeom>
+          <a:noFill/>
+        </p:spPr>
+        <p:txBody>
+          <a:bodyPr wrap="square" anchor="t" lIns="0" rIns="0" tIns="0" bIns="0">
+            <a:spAutoFit/>
+          </a:bodyPr>
+          <a:lstStyle/>
+          <a:p>
+            <a:pPr algn="l">
+              <a:lnSpc>
+                <a:spcPct val="110000"/>
+              </a:lnSpc>
+            </a:pPr>
+            <a:r>
+              <a:rPr sz="1500" b="0" i="0">
+                <a:solidFill>
+                  <a:srgbClr val="C8D0E8"/>
                 </a:solidFill>
                 <a:latin typeface="Trebuchet MS"/>
               </a:rPr>
-              <a:t>Перевод текста в баллы делает человек. Мы фиксировали правила, но оценка остаётся интерпретацией.</a:t>
-            </a:r>
-          </a:p>
-        </p:txBody>
-      </p:sp>
-      <p:sp>
-        <p:nvSpPr>
-          <p:cNvPr id="10" name="Rounded Rectangle 9"/>
+              <a:t>Все модели ведут к внутреннему системному кризису, а не к внешнему врагу или простой неизбежности.</a:t>
+            </a:r>
+          </a:p>
+        </p:txBody>
+      </p:sp>
+      <p:sp>
+        <p:nvSpPr>
+          <p:cNvPr id="9" name="Oval 8"/>
           <p:cNvSpPr/>
           <p:nvPr/>
         </p:nvSpPr>
         <p:spPr>
           <a:xfrm>
-            <a:off x="822960" y="3895344"/>
-            <a:ext cx="10515600" cy="1024128"/>
-          </a:xfrm>
-          <a:prstGeom prst="roundRect">
-            <a:avLst>
-              <a:gd name="adj" fmla="val 8000"/>
-            </a:avLst>
+            <a:off x="868680" y="4572000"/>
+            <a:ext cx="365760" cy="365760"/>
+          </a:xfrm>
+          <a:prstGeom prst="ellipse">
+            <a:avLst/>
           </a:prstGeom>
           <a:solidFill>
-            <a:srgbClr val="F4F6FB"/>
+            <a:srgbClr val="D7263D"/>
           </a:solidFill>
           <a:ln>
             <a:noFill/>
@@ -6201,100 +7274,98 @@
       </p:sp>
       <p:sp>
         <p:nvSpPr>
+          <p:cNvPr id="10" name="TextBox 9"/>
+          <p:cNvSpPr txBox="1"/>
+          <p:nvPr/>
+        </p:nvSpPr>
+        <p:spPr>
+          <a:xfrm>
+            <a:off x="1463040" y="4480560"/>
+            <a:ext cx="9692640" cy="457200"/>
+          </a:xfrm>
+          <a:prstGeom prst="rect">
+            <a:avLst/>
+          </a:prstGeom>
+          <a:noFill/>
+        </p:spPr>
+        <p:txBody>
+          <a:bodyPr wrap="square" anchor="t" lIns="0" rIns="0" tIns="0" bIns="0">
+            <a:spAutoFit/>
+          </a:bodyPr>
+          <a:lstStyle/>
+          <a:p>
+            <a:pPr algn="l">
+              <a:lnSpc>
+                <a:spcPct val="100000"/>
+              </a:lnSpc>
+            </a:pPr>
+            <a:r>
+              <a:rPr sz="1800" b="1" i="0">
+                <a:solidFill>
+                  <a:srgbClr val="CADCFC"/>
+                </a:solidFill>
+                <a:latin typeface="Georgia"/>
+              </a:rPr>
+              <a:t>Модели «площе» людей</a:t>
+            </a:r>
+          </a:p>
+        </p:txBody>
+      </p:sp>
+      <p:sp>
+        <p:nvSpPr>
           <p:cNvPr id="11" name="TextBox 10"/>
           <p:cNvSpPr txBox="1"/>
           <p:nvPr/>
         </p:nvSpPr>
         <p:spPr>
           <a:xfrm>
-            <a:off x="1143000" y="4041648"/>
-            <a:ext cx="4023360" cy="731520"/>
-          </a:xfrm>
-          <a:prstGeom prst="rect">
-            <a:avLst/>
-          </a:prstGeom>
-          <a:noFill/>
-        </p:spPr>
-        <p:txBody>
-          <a:bodyPr wrap="square" anchor="ctr" lIns="0" rIns="0" tIns="0" bIns="0">
-            <a:spAutoFit/>
-          </a:bodyPr>
-          <a:lstStyle/>
-          <a:p>
-            <a:pPr algn="l">
-              <a:lnSpc>
-                <a:spcPct val="100000"/>
-              </a:lnSpc>
-            </a:pPr>
-            <a:r>
-              <a:rPr sz="1750" b="1" i="0">
-                <a:solidFill>
-                  <a:srgbClr val="1E2761"/>
-                </a:solidFill>
-                <a:latin typeface="Georgia"/>
-              </a:rPr>
-              <a:t>Разный охват серий</a:t>
-            </a:r>
-          </a:p>
-        </p:txBody>
-      </p:sp>
-      <p:sp>
-        <p:nvSpPr>
-          <p:cNvPr id="12" name="TextBox 11"/>
-          <p:cNvSpPr txBox="1"/>
-          <p:nvPr/>
-        </p:nvSpPr>
-        <p:spPr>
-          <a:xfrm>
-            <a:off x="5349240" y="4041648"/>
-            <a:ext cx="5760720" cy="777240"/>
-          </a:xfrm>
-          <a:prstGeom prst="rect">
-            <a:avLst/>
-          </a:prstGeom>
-          <a:noFill/>
-        </p:spPr>
-        <p:txBody>
-          <a:bodyPr wrap="square" anchor="ctr" lIns="0" rIns="0" tIns="0" bIns="0">
-            <a:spAutoFit/>
-          </a:bodyPr>
-          <a:lstStyle/>
-          <a:p>
-            <a:pPr algn="l">
-              <a:lnSpc>
-                <a:spcPct val="112000"/>
-              </a:lnSpc>
-            </a:pPr>
-            <a:r>
-              <a:rPr sz="1450" b="0" i="0">
-                <a:solidFill>
-                  <a:srgbClr val="6B7280"/>
+            <a:off x="1463040" y="4937760"/>
+            <a:ext cx="9692640" cy="502920"/>
+          </a:xfrm>
+          <a:prstGeom prst="rect">
+            <a:avLst/>
+          </a:prstGeom>
+          <a:noFill/>
+        </p:spPr>
+        <p:txBody>
+          <a:bodyPr wrap="square" anchor="t" lIns="0" rIns="0" tIns="0" bIns="0">
+            <a:spAutoFit/>
+          </a:bodyPr>
+          <a:lstStyle/>
+          <a:p>
+            <a:pPr algn="l">
+              <a:lnSpc>
+                <a:spcPct val="110000"/>
+              </a:lnSpc>
+            </a:pPr>
+            <a:r>
+              <a:rPr sz="1500" b="0" i="0">
+                <a:solidFill>
+                  <a:srgbClr val="C8D0E8"/>
                 </a:solidFill>
                 <a:latin typeface="Trebuchet MS"/>
               </a:rPr>
-              <a:t>У ChatGPT и Gemini — по 4 серии, у Claude — по одной: интерфейсы дают разные режимы.</a:t>
-            </a:r>
-          </a:p>
-        </p:txBody>
-      </p:sp>
-      <p:sp>
-        <p:nvSpPr>
-          <p:cNvPr id="13" name="Rounded Rectangle 12"/>
+              <a:t>По оси Y нейросети осторожнее: безличные структуры вместо конкретных решений живых историков.</a:t>
+            </a:r>
+          </a:p>
+        </p:txBody>
+      </p:sp>
+      <p:sp>
+        <p:nvSpPr>
+          <p:cNvPr id="12" name="Oval 11"/>
           <p:cNvSpPr/>
           <p:nvPr/>
         </p:nvSpPr>
         <p:spPr>
           <a:xfrm>
-            <a:off x="822960" y="5065776"/>
-            <a:ext cx="10515600" cy="1024128"/>
-          </a:xfrm>
-          <a:prstGeom prst="roundRect">
-            <a:avLst>
-              <a:gd name="adj" fmla="val 8000"/>
-            </a:avLst>
+            <a:off x="868680" y="5532120"/>
+            <a:ext cx="365760" cy="365760"/>
+          </a:xfrm>
+          <a:prstGeom prst="ellipse">
+            <a:avLst/>
           </a:prstGeom>
           <a:solidFill>
-            <a:srgbClr val="F4F6FB"/>
+            <a:srgbClr val="D7263D"/>
           </a:solidFill>
           <a:ln>
             <a:noFill/>
@@ -6325,78 +7396,78 @@
       </p:sp>
       <p:sp>
         <p:nvSpPr>
+          <p:cNvPr id="13" name="TextBox 12"/>
+          <p:cNvSpPr txBox="1"/>
+          <p:nvPr/>
+        </p:nvSpPr>
+        <p:spPr>
+          <a:xfrm>
+            <a:off x="1463040" y="5440680"/>
+            <a:ext cx="9692640" cy="457200"/>
+          </a:xfrm>
+          <a:prstGeom prst="rect">
+            <a:avLst/>
+          </a:prstGeom>
+          <a:noFill/>
+        </p:spPr>
+        <p:txBody>
+          <a:bodyPr wrap="square" anchor="t" lIns="0" rIns="0" tIns="0" bIns="0">
+            <a:spAutoFit/>
+          </a:bodyPr>
+          <a:lstStyle/>
+          <a:p>
+            <a:pPr algn="l">
+              <a:lnSpc>
+                <a:spcPct val="100000"/>
+              </a:lnSpc>
+            </a:pPr>
+            <a:r>
+              <a:rPr sz="1800" b="1" i="0">
+                <a:solidFill>
+                  <a:srgbClr val="CADCFC"/>
+                </a:solidFill>
+                <a:latin typeface="Georgia"/>
+              </a:rPr>
+              <a:t>Bias виден в источниках</a:t>
+            </a:r>
+          </a:p>
+        </p:txBody>
+      </p:sp>
+      <p:sp>
+        <p:nvSpPr>
           <p:cNvPr id="14" name="TextBox 13"/>
           <p:cNvSpPr txBox="1"/>
           <p:nvPr/>
         </p:nvSpPr>
         <p:spPr>
           <a:xfrm>
-            <a:off x="1143000" y="5212080"/>
-            <a:ext cx="4023360" cy="731520"/>
-          </a:xfrm>
-          <a:prstGeom prst="rect">
-            <a:avLst/>
-          </a:prstGeom>
-          <a:noFill/>
-        </p:spPr>
-        <p:txBody>
-          <a:bodyPr wrap="square" anchor="ctr" lIns="0" rIns="0" tIns="0" bIns="0">
-            <a:spAutoFit/>
-          </a:bodyPr>
-          <a:lstStyle/>
-          <a:p>
-            <a:pPr algn="l">
-              <a:lnSpc>
-                <a:spcPct val="100000"/>
-              </a:lnSpc>
-            </a:pPr>
-            <a:r>
-              <a:rPr sz="1750" b="1" i="0">
-                <a:solidFill>
-                  <a:srgbClr val="1E2761"/>
-                </a:solidFill>
-                <a:latin typeface="Georgia"/>
-              </a:rPr>
-              <a:t>Цифры — для иллюстрации</a:t>
-            </a:r>
-          </a:p>
-        </p:txBody>
-      </p:sp>
-      <p:sp>
-        <p:nvSpPr>
-          <p:cNvPr id="15" name="TextBox 14"/>
-          <p:cNvSpPr txBox="1"/>
-          <p:nvPr/>
-        </p:nvSpPr>
-        <p:spPr>
-          <a:xfrm>
-            <a:off x="5349240" y="5212080"/>
-            <a:ext cx="5760720" cy="777240"/>
-          </a:xfrm>
-          <a:prstGeom prst="rect">
-            <a:avLst/>
-          </a:prstGeom>
-          <a:noFill/>
-        </p:spPr>
-        <p:txBody>
-          <a:bodyPr wrap="square" anchor="ctr" lIns="0" rIns="0" tIns="0" bIns="0">
-            <a:spAutoFit/>
-          </a:bodyPr>
-          <a:lstStyle/>
-          <a:p>
-            <a:pPr algn="l">
-              <a:lnSpc>
-                <a:spcPct val="112000"/>
-              </a:lnSpc>
-            </a:pPr>
-            <a:r>
-              <a:rPr sz="1450" b="0" i="0">
-                <a:solidFill>
-                  <a:srgbClr val="6B7280"/>
+            <a:off x="1463040" y="5897880"/>
+            <a:ext cx="9692640" cy="502920"/>
+          </a:xfrm>
+          <a:prstGeom prst="rect">
+            <a:avLst/>
+          </a:prstGeom>
+          <a:noFill/>
+        </p:spPr>
+        <p:txBody>
+          <a:bodyPr wrap="square" anchor="t" lIns="0" rIns="0" tIns="0" bIns="0">
+            <a:spAutoFit/>
+          </a:bodyPr>
+          <a:lstStyle/>
+          <a:p>
+            <a:pPr algn="l">
+              <a:lnSpc>
+                <a:spcPct val="110000"/>
+              </a:lnSpc>
+            </a:pPr>
+            <a:r>
+              <a:rPr sz="1500" b="0" i="0">
+                <a:solidFill>
+                  <a:srgbClr val="C8D0E8"/>
                 </a:solidFill>
                 <a:latin typeface="Trebuchet MS"/>
               </a:rPr>
-              <a:t>Проценты и цитаты в ответах моделей не верифицировались против первоисточников.</a:t>
+              <a:t>Региональный сдвиг есть в подборе ссылок — но на итоговую интерпретацию влияет слабо.</a:t>
             </a:r>
           </a:p>
         </p:txBody>
@@ -6434,6 +7505,603 @@
             <a:avLst/>
           </a:prstGeom>
           <a:solidFill>
+            <a:srgbClr val="FFFFFF"/>
+          </a:solidFill>
+          <a:ln>
+            <a:noFill/>
+          </a:ln>
+          <a:effectLst/>
+        </p:spPr>
+        <p:style>
+          <a:lnRef idx="1">
+            <a:schemeClr val="accent1"/>
+          </a:lnRef>
+          <a:fillRef idx="3">
+            <a:schemeClr val="accent1"/>
+          </a:fillRef>
+          <a:effectRef idx="2">
+            <a:schemeClr val="accent1"/>
+          </a:effectRef>
+          <a:fontRef idx="minor">
+            <a:schemeClr val="lt1"/>
+          </a:fontRef>
+        </p:style>
+        <p:txBody>
+          <a:bodyPr rtlCol="0" anchor="ctr"/>
+          <a:lstStyle/>
+          <a:p>
+            <a:pPr algn="ctr"/>
+          </a:p>
+        </p:txBody>
+      </p:sp>
+      <p:sp>
+        <p:nvSpPr>
+          <p:cNvPr id="3" name="TextBox 2"/>
+          <p:cNvSpPr txBox="1"/>
+          <p:nvPr/>
+        </p:nvSpPr>
+        <p:spPr>
+          <a:xfrm>
+            <a:off x="822960" y="502920"/>
+            <a:ext cx="10515600" cy="640080"/>
+          </a:xfrm>
+          <a:prstGeom prst="rect">
+            <a:avLst/>
+          </a:prstGeom>
+          <a:noFill/>
+        </p:spPr>
+        <p:txBody>
+          <a:bodyPr wrap="square" anchor="t" lIns="0" rIns="0" tIns="0" bIns="0">
+            <a:spAutoFit/>
+          </a:bodyPr>
+          <a:lstStyle/>
+          <a:p>
+            <a:pPr algn="l">
+              <a:lnSpc>
+                <a:spcPct val="100000"/>
+              </a:lnSpc>
+            </a:pPr>
+            <a:r>
+              <a:rPr sz="3200" b="1" i="0">
+                <a:solidFill>
+                  <a:srgbClr val="1E2761"/>
+                </a:solidFill>
+                <a:latin typeface="Georgia"/>
+              </a:rPr>
+              <a:t>Честные ограничения</a:t>
+            </a:r>
+          </a:p>
+        </p:txBody>
+      </p:sp>
+      <p:sp>
+        <p:nvSpPr>
+          <p:cNvPr id="4" name="Rounded Rectangle 3"/>
+          <p:cNvSpPr/>
+          <p:nvPr/>
+        </p:nvSpPr>
+        <p:spPr>
+          <a:xfrm>
+            <a:off x="822960" y="1554480"/>
+            <a:ext cx="10515600" cy="1024128"/>
+          </a:xfrm>
+          <a:prstGeom prst="roundRect">
+            <a:avLst>
+              <a:gd name="adj" fmla="val 8000"/>
+            </a:avLst>
+          </a:prstGeom>
+          <a:solidFill>
+            <a:srgbClr val="F4F6FB"/>
+          </a:solidFill>
+          <a:ln>
+            <a:noFill/>
+          </a:ln>
+          <a:effectLst/>
+        </p:spPr>
+        <p:style>
+          <a:lnRef idx="1">
+            <a:schemeClr val="accent1"/>
+          </a:lnRef>
+          <a:fillRef idx="3">
+            <a:schemeClr val="accent1"/>
+          </a:fillRef>
+          <a:effectRef idx="2">
+            <a:schemeClr val="accent1"/>
+          </a:effectRef>
+          <a:fontRef idx="minor">
+            <a:schemeClr val="lt1"/>
+          </a:fontRef>
+        </p:style>
+        <p:txBody>
+          <a:bodyPr rtlCol="0" anchor="ctr"/>
+          <a:lstStyle/>
+          <a:p>
+            <a:pPr algn="ctr"/>
+          </a:p>
+        </p:txBody>
+      </p:sp>
+      <p:sp>
+        <p:nvSpPr>
+          <p:cNvPr id="5" name="TextBox 4"/>
+          <p:cNvSpPr txBox="1"/>
+          <p:nvPr/>
+        </p:nvSpPr>
+        <p:spPr>
+          <a:xfrm>
+            <a:off x="1143000" y="1700784"/>
+            <a:ext cx="4023360" cy="731520"/>
+          </a:xfrm>
+          <a:prstGeom prst="rect">
+            <a:avLst/>
+          </a:prstGeom>
+          <a:noFill/>
+        </p:spPr>
+        <p:txBody>
+          <a:bodyPr wrap="square" anchor="ctr" lIns="0" rIns="0" tIns="0" bIns="0">
+            <a:spAutoFit/>
+          </a:bodyPr>
+          <a:lstStyle/>
+          <a:p>
+            <a:pPr algn="l">
+              <a:lnSpc>
+                <a:spcPct val="100000"/>
+              </a:lnSpc>
+            </a:pPr>
+            <a:r>
+              <a:rPr sz="1750" b="1" i="0">
+                <a:solidFill>
+                  <a:srgbClr val="1E2761"/>
+                </a:solidFill>
+                <a:latin typeface="Georgia"/>
+              </a:rPr>
+              <a:t>Это снимок, а не приговор</a:t>
+            </a:r>
+          </a:p>
+        </p:txBody>
+      </p:sp>
+      <p:sp>
+        <p:nvSpPr>
+          <p:cNvPr id="6" name="TextBox 5"/>
+          <p:cNvSpPr txBox="1"/>
+          <p:nvPr/>
+        </p:nvSpPr>
+        <p:spPr>
+          <a:xfrm>
+            <a:off x="5349240" y="1700784"/>
+            <a:ext cx="5760720" cy="777240"/>
+          </a:xfrm>
+          <a:prstGeom prst="rect">
+            <a:avLst/>
+          </a:prstGeom>
+          <a:noFill/>
+        </p:spPr>
+        <p:txBody>
+          <a:bodyPr wrap="square" anchor="ctr" lIns="0" rIns="0" tIns="0" bIns="0">
+            <a:spAutoFit/>
+          </a:bodyPr>
+          <a:lstStyle/>
+          <a:p>
+            <a:pPr algn="l">
+              <a:lnSpc>
+                <a:spcPct val="112000"/>
+              </a:lnSpc>
+            </a:pPr>
+            <a:r>
+              <a:rPr sz="1450" b="0" i="0">
+                <a:solidFill>
+                  <a:srgbClr val="6B7280"/>
+                </a:solidFill>
+                <a:latin typeface="Trebuchet MS"/>
+              </a:rPr>
+              <a:t>Баллы описывают поведение моделей в конкретных промптах, датах и режимах — не «истину» о модели.</a:t>
+            </a:r>
+          </a:p>
+        </p:txBody>
+      </p:sp>
+      <p:sp>
+        <p:nvSpPr>
+          <p:cNvPr id="7" name="Rounded Rectangle 6"/>
+          <p:cNvSpPr/>
+          <p:nvPr/>
+        </p:nvSpPr>
+        <p:spPr>
+          <a:xfrm>
+            <a:off x="822960" y="2724912"/>
+            <a:ext cx="10515600" cy="1024128"/>
+          </a:xfrm>
+          <a:prstGeom prst="roundRect">
+            <a:avLst>
+              <a:gd name="adj" fmla="val 8000"/>
+            </a:avLst>
+          </a:prstGeom>
+          <a:solidFill>
+            <a:srgbClr val="F4F6FB"/>
+          </a:solidFill>
+          <a:ln>
+            <a:noFill/>
+          </a:ln>
+          <a:effectLst/>
+        </p:spPr>
+        <p:style>
+          <a:lnRef idx="1">
+            <a:schemeClr val="accent1"/>
+          </a:lnRef>
+          <a:fillRef idx="3">
+            <a:schemeClr val="accent1"/>
+          </a:fillRef>
+          <a:effectRef idx="2">
+            <a:schemeClr val="accent1"/>
+          </a:effectRef>
+          <a:fontRef idx="minor">
+            <a:schemeClr val="lt1"/>
+          </a:fontRef>
+        </p:style>
+        <p:txBody>
+          <a:bodyPr rtlCol="0" anchor="ctr"/>
+          <a:lstStyle/>
+          <a:p>
+            <a:pPr algn="ctr"/>
+          </a:p>
+        </p:txBody>
+      </p:sp>
+      <p:sp>
+        <p:nvSpPr>
+          <p:cNvPr id="8" name="TextBox 7"/>
+          <p:cNvSpPr txBox="1"/>
+          <p:nvPr/>
+        </p:nvSpPr>
+        <p:spPr>
+          <a:xfrm>
+            <a:off x="1143000" y="2871216"/>
+            <a:ext cx="4023360" cy="731520"/>
+          </a:xfrm>
+          <a:prstGeom prst="rect">
+            <a:avLst/>
+          </a:prstGeom>
+          <a:noFill/>
+        </p:spPr>
+        <p:txBody>
+          <a:bodyPr wrap="square" anchor="ctr" lIns="0" rIns="0" tIns="0" bIns="0">
+            <a:spAutoFit/>
+          </a:bodyPr>
+          <a:lstStyle/>
+          <a:p>
+            <a:pPr algn="l">
+              <a:lnSpc>
+                <a:spcPct val="100000"/>
+              </a:lnSpc>
+            </a:pPr>
+            <a:r>
+              <a:rPr sz="1750" b="1" i="0">
+                <a:solidFill>
+                  <a:srgbClr val="1E2761"/>
+                </a:solidFill>
+                <a:latin typeface="Georgia"/>
+              </a:rPr>
+              <a:t>Субъективность кодировки</a:t>
+            </a:r>
+          </a:p>
+        </p:txBody>
+      </p:sp>
+      <p:sp>
+        <p:nvSpPr>
+          <p:cNvPr id="9" name="TextBox 8"/>
+          <p:cNvSpPr txBox="1"/>
+          <p:nvPr/>
+        </p:nvSpPr>
+        <p:spPr>
+          <a:xfrm>
+            <a:off x="5349240" y="2871216"/>
+            <a:ext cx="5760720" cy="777240"/>
+          </a:xfrm>
+          <a:prstGeom prst="rect">
+            <a:avLst/>
+          </a:prstGeom>
+          <a:noFill/>
+        </p:spPr>
+        <p:txBody>
+          <a:bodyPr wrap="square" anchor="ctr" lIns="0" rIns="0" tIns="0" bIns="0">
+            <a:spAutoFit/>
+          </a:bodyPr>
+          <a:lstStyle/>
+          <a:p>
+            <a:pPr algn="l">
+              <a:lnSpc>
+                <a:spcPct val="112000"/>
+              </a:lnSpc>
+            </a:pPr>
+            <a:r>
+              <a:rPr sz="1450" b="0" i="0">
+                <a:solidFill>
+                  <a:srgbClr val="6B7280"/>
+                </a:solidFill>
+                <a:latin typeface="Trebuchet MS"/>
+              </a:rPr>
+              <a:t>Перевод текста в баллы делает человек. Мы фиксировали правила, но оценка остаётся интерпретацией.</a:t>
+            </a:r>
+          </a:p>
+        </p:txBody>
+      </p:sp>
+      <p:sp>
+        <p:nvSpPr>
+          <p:cNvPr id="10" name="Rounded Rectangle 9"/>
+          <p:cNvSpPr/>
+          <p:nvPr/>
+        </p:nvSpPr>
+        <p:spPr>
+          <a:xfrm>
+            <a:off x="822960" y="3895344"/>
+            <a:ext cx="10515600" cy="1024128"/>
+          </a:xfrm>
+          <a:prstGeom prst="roundRect">
+            <a:avLst>
+              <a:gd name="adj" fmla="val 8000"/>
+            </a:avLst>
+          </a:prstGeom>
+          <a:solidFill>
+            <a:srgbClr val="F4F6FB"/>
+          </a:solidFill>
+          <a:ln>
+            <a:noFill/>
+          </a:ln>
+          <a:effectLst/>
+        </p:spPr>
+        <p:style>
+          <a:lnRef idx="1">
+            <a:schemeClr val="accent1"/>
+          </a:lnRef>
+          <a:fillRef idx="3">
+            <a:schemeClr val="accent1"/>
+          </a:fillRef>
+          <a:effectRef idx="2">
+            <a:schemeClr val="accent1"/>
+          </a:effectRef>
+          <a:fontRef idx="minor">
+            <a:schemeClr val="lt1"/>
+          </a:fontRef>
+        </p:style>
+        <p:txBody>
+          <a:bodyPr rtlCol="0" anchor="ctr"/>
+          <a:lstStyle/>
+          <a:p>
+            <a:pPr algn="ctr"/>
+          </a:p>
+        </p:txBody>
+      </p:sp>
+      <p:sp>
+        <p:nvSpPr>
+          <p:cNvPr id="11" name="TextBox 10"/>
+          <p:cNvSpPr txBox="1"/>
+          <p:nvPr/>
+        </p:nvSpPr>
+        <p:spPr>
+          <a:xfrm>
+            <a:off x="1143000" y="4041648"/>
+            <a:ext cx="4023360" cy="731520"/>
+          </a:xfrm>
+          <a:prstGeom prst="rect">
+            <a:avLst/>
+          </a:prstGeom>
+          <a:noFill/>
+        </p:spPr>
+        <p:txBody>
+          <a:bodyPr wrap="square" anchor="ctr" lIns="0" rIns="0" tIns="0" bIns="0">
+            <a:spAutoFit/>
+          </a:bodyPr>
+          <a:lstStyle/>
+          <a:p>
+            <a:pPr algn="l">
+              <a:lnSpc>
+                <a:spcPct val="100000"/>
+              </a:lnSpc>
+            </a:pPr>
+            <a:r>
+              <a:rPr sz="1750" b="1" i="0">
+                <a:solidFill>
+                  <a:srgbClr val="1E2761"/>
+                </a:solidFill>
+                <a:latin typeface="Georgia"/>
+              </a:rPr>
+              <a:t>Разный охват серий</a:t>
+            </a:r>
+          </a:p>
+        </p:txBody>
+      </p:sp>
+      <p:sp>
+        <p:nvSpPr>
+          <p:cNvPr id="12" name="TextBox 11"/>
+          <p:cNvSpPr txBox="1"/>
+          <p:nvPr/>
+        </p:nvSpPr>
+        <p:spPr>
+          <a:xfrm>
+            <a:off x="5349240" y="4041648"/>
+            <a:ext cx="5760720" cy="777240"/>
+          </a:xfrm>
+          <a:prstGeom prst="rect">
+            <a:avLst/>
+          </a:prstGeom>
+          <a:noFill/>
+        </p:spPr>
+        <p:txBody>
+          <a:bodyPr wrap="square" anchor="ctr" lIns="0" rIns="0" tIns="0" bIns="0">
+            <a:spAutoFit/>
+          </a:bodyPr>
+          <a:lstStyle/>
+          <a:p>
+            <a:pPr algn="l">
+              <a:lnSpc>
+                <a:spcPct val="112000"/>
+              </a:lnSpc>
+            </a:pPr>
+            <a:r>
+              <a:rPr sz="1450" b="0" i="0">
+                <a:solidFill>
+                  <a:srgbClr val="6B7280"/>
+                </a:solidFill>
+                <a:latin typeface="Trebuchet MS"/>
+              </a:rPr>
+              <a:t>У ChatGPT и Gemini — по 4 серии, у Claude — по одной: интерфейсы дают разные режимы.</a:t>
+            </a:r>
+          </a:p>
+        </p:txBody>
+      </p:sp>
+      <p:sp>
+        <p:nvSpPr>
+          <p:cNvPr id="13" name="Rounded Rectangle 12"/>
+          <p:cNvSpPr/>
+          <p:nvPr/>
+        </p:nvSpPr>
+        <p:spPr>
+          <a:xfrm>
+            <a:off x="822960" y="5065776"/>
+            <a:ext cx="10515600" cy="1024128"/>
+          </a:xfrm>
+          <a:prstGeom prst="roundRect">
+            <a:avLst>
+              <a:gd name="adj" fmla="val 8000"/>
+            </a:avLst>
+          </a:prstGeom>
+          <a:solidFill>
+            <a:srgbClr val="F4F6FB"/>
+          </a:solidFill>
+          <a:ln>
+            <a:noFill/>
+          </a:ln>
+          <a:effectLst/>
+        </p:spPr>
+        <p:style>
+          <a:lnRef idx="1">
+            <a:schemeClr val="accent1"/>
+          </a:lnRef>
+          <a:fillRef idx="3">
+            <a:schemeClr val="accent1"/>
+          </a:fillRef>
+          <a:effectRef idx="2">
+            <a:schemeClr val="accent1"/>
+          </a:effectRef>
+          <a:fontRef idx="minor">
+            <a:schemeClr val="lt1"/>
+          </a:fontRef>
+        </p:style>
+        <p:txBody>
+          <a:bodyPr rtlCol="0" anchor="ctr"/>
+          <a:lstStyle/>
+          <a:p>
+            <a:pPr algn="ctr"/>
+          </a:p>
+        </p:txBody>
+      </p:sp>
+      <p:sp>
+        <p:nvSpPr>
+          <p:cNvPr id="14" name="TextBox 13"/>
+          <p:cNvSpPr txBox="1"/>
+          <p:nvPr/>
+        </p:nvSpPr>
+        <p:spPr>
+          <a:xfrm>
+            <a:off x="1143000" y="5212080"/>
+            <a:ext cx="4023360" cy="731520"/>
+          </a:xfrm>
+          <a:prstGeom prst="rect">
+            <a:avLst/>
+          </a:prstGeom>
+          <a:noFill/>
+        </p:spPr>
+        <p:txBody>
+          <a:bodyPr wrap="square" anchor="ctr" lIns="0" rIns="0" tIns="0" bIns="0">
+            <a:spAutoFit/>
+          </a:bodyPr>
+          <a:lstStyle/>
+          <a:p>
+            <a:pPr algn="l">
+              <a:lnSpc>
+                <a:spcPct val="100000"/>
+              </a:lnSpc>
+            </a:pPr>
+            <a:r>
+              <a:rPr sz="1750" b="1" i="0">
+                <a:solidFill>
+                  <a:srgbClr val="1E2761"/>
+                </a:solidFill>
+                <a:latin typeface="Georgia"/>
+              </a:rPr>
+              <a:t>Цифры — для иллюстрации</a:t>
+            </a:r>
+          </a:p>
+        </p:txBody>
+      </p:sp>
+      <p:sp>
+        <p:nvSpPr>
+          <p:cNvPr id="15" name="TextBox 14"/>
+          <p:cNvSpPr txBox="1"/>
+          <p:nvPr/>
+        </p:nvSpPr>
+        <p:spPr>
+          <a:xfrm>
+            <a:off x="5349240" y="5212080"/>
+            <a:ext cx="5760720" cy="777240"/>
+          </a:xfrm>
+          <a:prstGeom prst="rect">
+            <a:avLst/>
+          </a:prstGeom>
+          <a:noFill/>
+        </p:spPr>
+        <p:txBody>
+          <a:bodyPr wrap="square" anchor="ctr" lIns="0" rIns="0" tIns="0" bIns="0">
+            <a:spAutoFit/>
+          </a:bodyPr>
+          <a:lstStyle/>
+          <a:p>
+            <a:pPr algn="l">
+              <a:lnSpc>
+                <a:spcPct val="112000"/>
+              </a:lnSpc>
+            </a:pPr>
+            <a:r>
+              <a:rPr sz="1450" b="0" i="0">
+                <a:solidFill>
+                  <a:srgbClr val="6B7280"/>
+                </a:solidFill>
+                <a:latin typeface="Trebuchet MS"/>
+              </a:rPr>
+              <a:t>Проценты и цитаты в ответах моделей не верифицировались против первоисточников.</a:t>
+            </a:r>
+          </a:p>
+        </p:txBody>
+      </p:sp>
+    </p:spTree>
+  </p:cSld>
+  <p:clrMapOvr>
+    <a:masterClrMapping/>
+  </p:clrMapOvr>
+</p:sld>
+</file>
+
+<file path=ppt/slides/slide16.xml><?xml version="1.0" encoding="utf-8"?>
+<p:sld xmlns:a="http://schemas.openxmlformats.org/drawingml/2006/main" xmlns:p="http://schemas.openxmlformats.org/presentationml/2006/main" xmlns:r="http://schemas.openxmlformats.org/officeDocument/2006/relationships">
+  <p:cSld>
+    <p:spTree>
+      <p:nvGrpSpPr>
+        <p:cNvPr id="1" name=""/>
+        <p:cNvGrpSpPr/>
+        <p:nvPr/>
+      </p:nvGrpSpPr>
+      <p:grpSpPr/>
+      <p:sp>
+        <p:nvSpPr>
+          <p:cNvPr id="2" name="Rectangle 1"/>
+          <p:cNvSpPr/>
+          <p:nvPr/>
+        </p:nvSpPr>
+        <p:spPr>
+          <a:xfrm>
+            <a:off x="0" y="0"/>
+            <a:ext cx="12191695" cy="6858000"/>
+          </a:xfrm>
+          <a:prstGeom prst="rect">
+            <a:avLst/>
+          </a:prstGeom>
+          <a:solidFill>
             <a:srgbClr val="1E2761"/>
           </a:solidFill>
           <a:ln>
@@ -6764,7 +8432,7 @@
                 </a:solidFill>
                 <a:latin typeface="Georgia"/>
               </a:rPr>
-              <a:t>Разрыв проходит человек — машина</a:t>
+              <a:t>Разрыв — между человеком и машиной</a:t>
             </a:r>
           </a:p>
         </p:txBody>
@@ -11466,7 +13134,7 @@
                 </a:solidFill>
                 <a:latin typeface="Trebuchet MS"/>
               </a:rPr>
-              <a:t>не стал внешне-обвинительным даже с поиском по рунету</a:t>
+              <a:t>не начал винить Запад даже с поиском по рунету</a:t>
             </a:r>
           </a:p>
         </p:txBody>

</xml_diff>